<commit_message>
docs: replace architecture source with DeckCraft
</commit_message>
<xml_diff>
--- a/docs/assets/raptor-soc-architecture.pptx
+++ b/docs/assets/raptor-soc-architecture.pptx
@@ -4387,7 +4387,7 @@
         <p:spPr>
           <a:xfrm>
             <a:off x="9398000" y="5270500"/>
-            <a:ext cx="2222500" cy="598535"/>
+            <a:ext cx="2222500" cy="594360"/>
           </a:xfrm>
           <a:prstGeom prst="rect">
             <a:avLst/>
@@ -4409,12 +4409,6 @@
               </a:rPr>
               <a:t>1024 x 16-bit</a:t>
             </a:r>
-            <a:endParaRPr sz="1100">
-              <a:solidFill>
-                <a:srgbClr val="334155"/>
-              </a:solidFill>
-              <a:latin typeface="Inter"/>
-            </a:endParaRPr>
           </a:p>
           <a:p>
             <a:pPr algn="ctr"/>
@@ -4425,14 +4419,8 @@
                 </a:solidFill>
                 <a:latin typeface="Inter"/>
               </a:rPr>
-              <a:t>Interior program @ 0</a:t>
+              <a:t>Blur kernel</a:t>
             </a:r>
-            <a:endParaRPr sz="1100">
-              <a:solidFill>
-                <a:srgbClr val="334155"/>
-              </a:solidFill>
-              <a:latin typeface="Inter"/>
-            </a:endParaRPr>
           </a:p>
           <a:p>
             <a:pPr algn="ctr"/>
@@ -4443,14 +4431,8 @@
                 </a:solidFill>
                 <a:latin typeface="Inter"/>
               </a:rPr>
-              <a:t>Border program @ 512</a:t>
+              <a:t>Brighten kernel</a:t>
             </a:r>
-            <a:endParaRPr sz="1100">
-              <a:solidFill>
-                <a:srgbClr val="334155"/>
-              </a:solidFill>
-              <a:latin typeface="Inter"/>
-            </a:endParaRPr>
           </a:p>
         </p:txBody>
       </p:sp>

</xml_diff>

<commit_message>
docs: update Phase 5 architecture diagram
</commit_message>
<xml_diff>
--- a/docs/assets/raptor-soc-architecture.pptx
+++ b/docs/assets/raptor-soc-architecture.pptx
@@ -2741,6 +2741,14 @@
 <file path=ppt/slides/slide1.xml><?xml version="1.0" encoding="utf-8"?>
 <p:sld xmlns:a="http://schemas.openxmlformats.org/drawingml/2006/main" xmlns:r="http://schemas.openxmlformats.org/officeDocument/2006/relationships" xmlns:p="http://schemas.openxmlformats.org/presentationml/2006/main">
   <p:cSld>
+    <p:bg>
+      <p:bgPr>
+        <a:solidFill>
+          <a:srgbClr val="FFFFFF"/>
+        </a:solidFill>
+        <a:effectLst/>
+      </p:bgPr>
+    </p:bg>
     <p:spTree>
       <p:nvGrpSpPr>
         <p:cNvPr id="1" name=""/>
@@ -2757,38 +2765,38 @@
       </p:grpSpPr>
       <p:sp>
         <p:nvSpPr>
-          <p:cNvPr id="260" name="TextBox 1"/>
+          <p:cNvPr id="313" name="TextBox 1"/>
           <p:cNvSpPr txBox="1"/>
           <p:nvPr/>
         </p:nvSpPr>
         <p:spPr>
           <a:xfrm>
-            <a:off x="508000" y="203200"/>
-            <a:ext cx="11176000" cy="521702"/>
-          </a:xfrm>
-          <a:prstGeom prst="rect">
-            <a:avLst/>
-          </a:prstGeom>
-        </p:spPr>
-        <p:txBody>
-          <a:bodyPr wrap="square" anchor="ctr">
-            <a:spAutoFit/>
+            <a:off x="444500" y="152400"/>
+            <a:ext cx="11303000" cy="411480"/>
+          </a:xfrm>
+          <a:prstGeom prst="rect">
+            <a:avLst/>
+          </a:prstGeom>
+        </p:spPr>
+        <p:txBody>
+          <a:bodyPr wrap="square" lIns="0" tIns="0" rIns="0" bIns="0" anchor="ctr">
+            <a:normAutofit fontScale="100000"/>
           </a:bodyPr>
           <a:lstStyle/>
           <a:p>
             <a:pPr algn="ctr"/>
             <a:r>
-              <a:rPr sz="2800" b="1">
-                <a:solidFill>
-                  <a:srgbClr val="111827"/>
+              <a:rPr sz="2700" b="1">
+                <a:solidFill>
+                  <a:srgbClr val="0F172A"/>
                 </a:solidFill>
                 <a:latin typeface="Inter"/>
               </a:rPr>
               <a:t>RAPTOR-SoC Architecture</a:t>
             </a:r>
-            <a:endParaRPr sz="2800" b="1">
+            <a:endParaRPr sz="2700" b="1">
               <a:solidFill>
-                <a:srgbClr val="111827"/>
+                <a:srgbClr val="0F172A"/>
               </a:solidFill>
               <a:latin typeface="Inter"/>
             </a:endParaRPr>
@@ -2797,36 +2805,36 @@
       </p:sp>
       <p:sp>
         <p:nvSpPr>
-          <p:cNvPr id="261" name="TextBox 2"/>
+          <p:cNvPr id="314" name="TextBox 2"/>
           <p:cNvSpPr txBox="1"/>
           <p:nvPr/>
         </p:nvSpPr>
         <p:spPr>
           <a:xfrm>
-            <a:off x="889000" y="698500"/>
-            <a:ext cx="10414000" cy="291205"/>
-          </a:xfrm>
-          <a:prstGeom prst="rect">
-            <a:avLst/>
-          </a:prstGeom>
-        </p:spPr>
-        <p:txBody>
-          <a:bodyPr wrap="square" anchor="ctr">
-            <a:spAutoFit/>
+            <a:off x="571500" y="609600"/>
+            <a:ext cx="11049000" cy="182880"/>
+          </a:xfrm>
+          <a:prstGeom prst="rect">
+            <a:avLst/>
+          </a:prstGeom>
+        </p:spPr>
+        <p:txBody>
+          <a:bodyPr wrap="square" lIns="0" tIns="0" rIns="0" bIns="0" anchor="ctr">
+            <a:normAutofit fontScale="100000"/>
           </a:bodyPr>
           <a:lstStyle/>
           <a:p>
             <a:pPr algn="ctr"/>
             <a:r>
-              <a:rPr sz="1300">
+              <a:rPr sz="1200" b="0">
                 <a:solidFill>
                   <a:srgbClr val="64748B"/>
                 </a:solidFill>
                 <a:latin typeface="Inter"/>
               </a:rPr>
-              <a:t>CPU-controlled SIMT GPU with AXI4-Lite control and shared memory</a:t>
+              <a:t>Dual-clock Phase 5 implementation • cached private memory • uncached shared GPU path</a:t>
             </a:r>
-            <a:endParaRPr sz="1300">
+            <a:endParaRPr sz="1200" b="0">
               <a:solidFill>
                 <a:srgbClr val="64748B"/>
               </a:solidFill>
@@ -2837,14 +2845,349 @@
       </p:sp>
       <p:sp>
         <p:nvSpPr>
-          <p:cNvPr id="262" name="Freeform 262"/>
+          <p:cNvPr id="315" name="Rectangle 3"/>
           <p:cNvSpPr/>
           <p:nvPr/>
         </p:nvSpPr>
         <p:spPr>
           <a:xfrm>
-            <a:off x="2159000" y="1435100"/>
-            <a:ext cx="2794000" cy="850900"/>
+            <a:off x="355600" y="1041400"/>
+            <a:ext cx="7035800" cy="5207000"/>
+          </a:xfrm>
+          <a:prstGeom prst="roundRect">
+            <a:avLst/>
+          </a:prstGeom>
+          <a:solidFill>
+            <a:srgbClr val="F8FAFC"/>
+          </a:solidFill>
+          <a:ln w="15240">
+            <a:solidFill>
+              <a:srgbClr val="CBD5E1"/>
+            </a:solidFill>
+          </a:ln>
+        </p:spPr>
+        <p:style>
+          <a:lnRef idx="2">
+            <a:schemeClr val="accent1">
+              <a:shade val="50000"/>
+            </a:schemeClr>
+          </a:lnRef>
+          <a:fillRef idx="1">
+            <a:schemeClr val="accent1"/>
+          </a:fillRef>
+          <a:effectRef idx="0">
+            <a:schemeClr val="accent1"/>
+          </a:effectRef>
+          <a:fontRef idx="minor">
+            <a:schemeClr val="lt1"/>
+          </a:fontRef>
+        </p:style>
+        <p:txBody>
+          <a:bodyPr anchor="ctr"/>
+          <a:lstStyle/>
+          <a:p/>
+        </p:txBody>
+      </p:sp>
+      <p:sp>
+        <p:nvSpPr>
+          <p:cNvPr id="316" name="Rectangle 4"/>
+          <p:cNvSpPr/>
+          <p:nvPr/>
+        </p:nvSpPr>
+        <p:spPr>
+          <a:xfrm>
+            <a:off x="8686800" y="1041400"/>
+            <a:ext cx="3149600" cy="5207000"/>
+          </a:xfrm>
+          <a:prstGeom prst="roundRect">
+            <a:avLst/>
+          </a:prstGeom>
+          <a:solidFill>
+            <a:srgbClr val="F7FEE7"/>
+          </a:solidFill>
+          <a:ln w="15240">
+            <a:solidFill>
+              <a:srgbClr val="BBF7D0"/>
+            </a:solidFill>
+          </a:ln>
+        </p:spPr>
+        <p:style>
+          <a:lnRef idx="2">
+            <a:schemeClr val="accent1">
+              <a:shade val="50000"/>
+            </a:schemeClr>
+          </a:lnRef>
+          <a:fillRef idx="1">
+            <a:schemeClr val="accent1"/>
+          </a:fillRef>
+          <a:effectRef idx="0">
+            <a:schemeClr val="accent1"/>
+          </a:effectRef>
+          <a:fontRef idx="minor">
+            <a:schemeClr val="lt1"/>
+          </a:fontRef>
+        </p:style>
+        <p:txBody>
+          <a:bodyPr anchor="ctr"/>
+          <a:lstStyle/>
+          <a:p/>
+        </p:txBody>
+      </p:sp>
+      <p:sp>
+        <p:nvSpPr>
+          <p:cNvPr id="317" name="Rectangle 5"/>
+          <p:cNvSpPr/>
+          <p:nvPr/>
+        </p:nvSpPr>
+        <p:spPr>
+          <a:xfrm>
+            <a:off x="7505700" y="1041400"/>
+            <a:ext cx="1066800" cy="5207000"/>
+          </a:xfrm>
+          <a:prstGeom prst="roundRect">
+            <a:avLst/>
+          </a:prstGeom>
+          <a:solidFill>
+            <a:srgbClr val="FAF5FF"/>
+          </a:solidFill>
+          <a:ln w="15240">
+            <a:solidFill>
+              <a:srgbClr val="D8B4FE"/>
+            </a:solidFill>
+          </a:ln>
+        </p:spPr>
+        <p:style>
+          <a:lnRef idx="2">
+            <a:schemeClr val="accent1">
+              <a:shade val="50000"/>
+            </a:schemeClr>
+          </a:lnRef>
+          <a:fillRef idx="1">
+            <a:schemeClr val="accent1"/>
+          </a:fillRef>
+          <a:effectRef idx="0">
+            <a:schemeClr val="accent1"/>
+          </a:effectRef>
+          <a:fontRef idx="minor">
+            <a:schemeClr val="lt1"/>
+          </a:fontRef>
+        </p:style>
+        <p:txBody>
+          <a:bodyPr anchor="ctr"/>
+          <a:lstStyle/>
+          <a:p/>
+        </p:txBody>
+      </p:sp>
+      <p:sp>
+        <p:nvSpPr>
+          <p:cNvPr id="318" name="TextBox 6"/>
+          <p:cNvSpPr txBox="1"/>
+          <p:nvPr/>
+        </p:nvSpPr>
+        <p:spPr>
+          <a:xfrm>
+            <a:off x="736600" y="1219200"/>
+            <a:ext cx="3759200" cy="175260"/>
+          </a:xfrm>
+          <a:prstGeom prst="rect">
+            <a:avLst/>
+          </a:prstGeom>
+        </p:spPr>
+        <p:txBody>
+          <a:bodyPr wrap="square" lIns="0" tIns="0" rIns="0" bIns="0" anchor="ctr">
+            <a:normAutofit fontScale="100000"/>
+          </a:bodyPr>
+          <a:lstStyle/>
+          <a:p>
+            <a:pPr algn="l"/>
+            <a:r>
+              <a:rPr sz="1150" b="1">
+                <a:solidFill>
+                  <a:srgbClr val="1D4ED8"/>
+                </a:solidFill>
+                <a:latin typeface="Inter"/>
+              </a:rPr>
+              <a:t>CPU / SYSTEM CLOCK DOMAIN</a:t>
+            </a:r>
+            <a:endParaRPr sz="1150" b="1">
+              <a:solidFill>
+                <a:srgbClr val="1D4ED8"/>
+              </a:solidFill>
+              <a:latin typeface="Inter"/>
+            </a:endParaRPr>
+          </a:p>
+        </p:txBody>
+      </p:sp>
+      <p:sp>
+        <p:nvSpPr>
+          <p:cNvPr id="319" name="TextBox 7"/>
+          <p:cNvSpPr txBox="1"/>
+          <p:nvPr/>
+        </p:nvSpPr>
+        <p:spPr>
+          <a:xfrm>
+            <a:off x="4572000" y="1219200"/>
+            <a:ext cx="1778000" cy="144780"/>
+          </a:xfrm>
+          <a:prstGeom prst="rect">
+            <a:avLst/>
+          </a:prstGeom>
+        </p:spPr>
+        <p:txBody>
+          <a:bodyPr wrap="square" lIns="0" tIns="0" rIns="0" bIns="0" anchor="ctr">
+            <a:normAutofit fontScale="100000"/>
+          </a:bodyPr>
+          <a:lstStyle/>
+          <a:p>
+            <a:pPr algn="r"/>
+            <a:r>
+              <a:rPr sz="950" b="1">
+                <a:solidFill>
+                  <a:srgbClr val="64748B"/>
+                </a:solidFill>
+                <a:latin typeface="Inter"/>
+              </a:rPr>
+              <a:t>100 MHz synthesized</a:t>
+            </a:r>
+            <a:endParaRPr sz="950" b="1">
+              <a:solidFill>
+                <a:srgbClr val="64748B"/>
+              </a:solidFill>
+              <a:latin typeface="Inter"/>
+            </a:endParaRPr>
+          </a:p>
+        </p:txBody>
+      </p:sp>
+      <p:sp>
+        <p:nvSpPr>
+          <p:cNvPr id="320" name="TextBox 8"/>
+          <p:cNvSpPr txBox="1"/>
+          <p:nvPr/>
+        </p:nvSpPr>
+        <p:spPr>
+          <a:xfrm>
+            <a:off x="8991600" y="1219200"/>
+            <a:ext cx="1524000" cy="160020"/>
+          </a:xfrm>
+          <a:prstGeom prst="rect">
+            <a:avLst/>
+          </a:prstGeom>
+        </p:spPr>
+        <p:txBody>
+          <a:bodyPr wrap="square" lIns="0" tIns="0" rIns="0" bIns="0" anchor="ctr">
+            <a:normAutofit fontScale="100000"/>
+          </a:bodyPr>
+          <a:lstStyle/>
+          <a:p>
+            <a:pPr algn="l"/>
+            <a:r>
+              <a:rPr sz="1050" b="1">
+                <a:solidFill>
+                  <a:srgbClr val="15803D"/>
+                </a:solidFill>
+                <a:latin typeface="Inter"/>
+              </a:rPr>
+              <a:t>GPU CLOCK DOMAIN</a:t>
+            </a:r>
+            <a:endParaRPr sz="1050" b="1">
+              <a:solidFill>
+                <a:srgbClr val="15803D"/>
+              </a:solidFill>
+              <a:latin typeface="Inter"/>
+            </a:endParaRPr>
+          </a:p>
+        </p:txBody>
+      </p:sp>
+      <p:sp>
+        <p:nvSpPr>
+          <p:cNvPr id="321" name="TextBox 9"/>
+          <p:cNvSpPr txBox="1"/>
+          <p:nvPr/>
+        </p:nvSpPr>
+        <p:spPr>
+          <a:xfrm>
+            <a:off x="10591800" y="1219200"/>
+            <a:ext cx="609600" cy="144780"/>
+          </a:xfrm>
+          <a:prstGeom prst="rect">
+            <a:avLst/>
+          </a:prstGeom>
+        </p:spPr>
+        <p:txBody>
+          <a:bodyPr wrap="square" lIns="0" tIns="0" rIns="0" bIns="0" anchor="ctr">
+            <a:normAutofit fontScale="100000"/>
+          </a:bodyPr>
+          <a:lstStyle/>
+          <a:p>
+            <a:pPr algn="r"/>
+            <a:r>
+              <a:rPr sz="950" b="1">
+                <a:solidFill>
+                  <a:srgbClr val="64748B"/>
+                </a:solidFill>
+                <a:latin typeface="Inter"/>
+              </a:rPr>
+              <a:t>50 MHz</a:t>
+            </a:r>
+            <a:endParaRPr sz="950" b="1">
+              <a:solidFill>
+                <a:srgbClr val="64748B"/>
+              </a:solidFill>
+              <a:latin typeface="Inter"/>
+            </a:endParaRPr>
+          </a:p>
+        </p:txBody>
+      </p:sp>
+      <p:sp>
+        <p:nvSpPr>
+          <p:cNvPr id="322" name="TextBox 10"/>
+          <p:cNvSpPr txBox="1"/>
+          <p:nvPr/>
+        </p:nvSpPr>
+        <p:spPr>
+          <a:xfrm>
+            <a:off x="7581900" y="1219200"/>
+            <a:ext cx="914400" cy="175260"/>
+          </a:xfrm>
+          <a:prstGeom prst="rect">
+            <a:avLst/>
+          </a:prstGeom>
+        </p:spPr>
+        <p:txBody>
+          <a:bodyPr wrap="square" lIns="0" tIns="0" rIns="0" bIns="0" anchor="ctr">
+            <a:normAutofit fontScale="100000"/>
+          </a:bodyPr>
+          <a:lstStyle/>
+          <a:p>
+            <a:pPr algn="ctr"/>
+            <a:r>
+              <a:rPr sz="1150" b="1">
+                <a:solidFill>
+                  <a:srgbClr val="7E22CE"/>
+                </a:solidFill>
+                <a:latin typeface="Inter"/>
+              </a:rPr>
+              <a:t>CDC</a:t>
+            </a:r>
+            <a:endParaRPr sz="1150" b="1">
+              <a:solidFill>
+                <a:srgbClr val="7E22CE"/>
+              </a:solidFill>
+              <a:latin typeface="Inter"/>
+            </a:endParaRPr>
+          </a:p>
+        </p:txBody>
+      </p:sp>
+      <p:sp>
+        <p:nvSpPr>
+          <p:cNvPr id="323" name="Freeform 323"/>
+          <p:cNvSpPr/>
+          <p:nvPr/>
+        </p:nvSpPr>
+        <p:spPr>
+          <a:xfrm>
+            <a:off x="2717800" y="2260600"/>
+            <a:ext cx="482600" cy="12700"/>
           </a:xfrm>
           <a:custGeom>
             <a:avLst/>
@@ -2853,113 +3196,7 @@
             <a:cxnLst/>
             <a:rect l="l" t="t" r="r" b="b"/>
             <a:pathLst>
-              <a:path w="100000" h="30455" fill="none">
-                <a:moveTo>
-                  <a:pt x="100000" y="0"/>
-                </a:moveTo>
-                <a:lnTo>
-                  <a:pt x="0" y="0"/>
-                </a:lnTo>
-                <a:lnTo>
-                  <a:pt x="0" y="30455"/>
-                </a:lnTo>
-              </a:path>
-            </a:pathLst>
-          </a:custGeom>
-          <a:ln w="25400">
-            <a:solidFill>
-              <a:srgbClr val="64748B"/>
-            </a:solidFill>
-            <a:tailEnd type="triangle" w="med" len="med"/>
-          </a:ln>
-        </p:spPr>
-        <p:style>
-          <a:lnRef idx="1">
-            <a:schemeClr val="accent1"/>
-          </a:lnRef>
-          <a:fillRef idx="0">
-            <a:schemeClr val="accent1"/>
-          </a:fillRef>
-          <a:effectRef idx="0">
-            <a:schemeClr val="accent1"/>
-          </a:effectRef>
-          <a:fontRef idx="minor">
-            <a:schemeClr val="tx1"/>
-          </a:fontRef>
-        </p:style>
-      </p:sp>
-      <p:sp>
-        <p:nvSpPr>
-          <p:cNvPr id="263" name="Freeform 263"/>
-          <p:cNvSpPr/>
-          <p:nvPr/>
-        </p:nvSpPr>
-        <p:spPr>
-          <a:xfrm>
-            <a:off x="7239000" y="1435100"/>
-            <a:ext cx="3810000" cy="596900"/>
-          </a:xfrm>
-          <a:custGeom>
-            <a:avLst/>
-            <a:gdLst/>
-            <a:ahLst/>
-            <a:cxnLst/>
-            <a:rect l="l" t="t" r="r" b="b"/>
-            <a:pathLst>
-              <a:path w="100000" h="15667" fill="none">
-                <a:moveTo>
-                  <a:pt x="0" y="0"/>
-                </a:moveTo>
-                <a:lnTo>
-                  <a:pt x="100000" y="0"/>
-                </a:lnTo>
-                <a:lnTo>
-                  <a:pt x="100000" y="15667"/>
-                </a:lnTo>
-              </a:path>
-            </a:pathLst>
-          </a:custGeom>
-          <a:ln w="25400">
-            <a:solidFill>
-              <a:srgbClr val="64748B"/>
-            </a:solidFill>
-            <a:tailEnd type="triangle" w="med" len="med"/>
-          </a:ln>
-        </p:spPr>
-        <p:style>
-          <a:lnRef idx="1">
-            <a:schemeClr val="accent1"/>
-          </a:lnRef>
-          <a:fillRef idx="0">
-            <a:schemeClr val="accent1"/>
-          </a:fillRef>
-          <a:effectRef idx="0">
-            <a:schemeClr val="accent1"/>
-          </a:effectRef>
-          <a:fontRef idx="minor">
-            <a:schemeClr val="tx1"/>
-          </a:fontRef>
-        </p:style>
-      </p:sp>
-      <p:sp>
-        <p:nvSpPr>
-          <p:cNvPr id="264" name="Freeform 264"/>
-          <p:cNvSpPr/>
-          <p:nvPr/>
-        </p:nvSpPr>
-        <p:spPr>
-          <a:xfrm>
-            <a:off x="3746500" y="3175000"/>
-            <a:ext cx="889000" cy="12700"/>
-          </a:xfrm>
-          <a:custGeom>
-            <a:avLst/>
-            <a:gdLst/>
-            <a:ahLst/>
-            <a:cxnLst/>
-            <a:rect l="l" t="t" r="r" b="b"/>
-            <a:pathLst>
-              <a:path w="100000" h="1429" fill="none">
+              <a:path w="100000" h="2632" fill="none">
                 <a:moveTo>
                   <a:pt x="0" y="0"/>
                 </a:moveTo>
@@ -2969,10 +3206,12 @@
               </a:path>
             </a:pathLst>
           </a:custGeom>
-          <a:ln w="38100">
+          <a:ln w="27940" cap="rnd">
             <a:solidFill>
               <a:srgbClr val="2563EB"/>
             </a:solidFill>
+            <a:prstDash val="solid"/>
+            <a:round/>
             <a:tailEnd type="triangle" w="med" len="med"/>
           </a:ln>
         </p:spPr>
@@ -2993,14 +3232,14 @@
       </p:sp>
       <p:sp>
         <p:nvSpPr>
-          <p:cNvPr id="265" name="Freeform 265"/>
+          <p:cNvPr id="324" name="Freeform 324"/>
           <p:cNvSpPr/>
           <p:nvPr/>
         </p:nvSpPr>
         <p:spPr>
           <a:xfrm>
-            <a:off x="7556500" y="3175000"/>
-            <a:ext cx="571500" cy="12700"/>
+            <a:off x="2717800" y="2590800"/>
+            <a:ext cx="482600" cy="660400"/>
           </a:xfrm>
           <a:custGeom>
             <a:avLst/>
@@ -3009,7 +3248,59 @@
             <a:cxnLst/>
             <a:rect l="l" t="t" r="r" b="b"/>
             <a:pathLst>
-              <a:path w="100000" h="2222" fill="none">
+              <a:path w="73077" h="100000" fill="none">
+                <a:moveTo>
+                  <a:pt x="0" y="0"/>
+                </a:moveTo>
+                <a:lnTo>
+                  <a:pt x="73077" y="100000"/>
+                </a:lnTo>
+              </a:path>
+            </a:pathLst>
+          </a:custGeom>
+          <a:ln w="27940" cap="rnd">
+            <a:solidFill>
+              <a:srgbClr val="2563EB"/>
+            </a:solidFill>
+            <a:prstDash val="solid"/>
+            <a:round/>
+            <a:tailEnd type="triangle" w="med" len="med"/>
+          </a:ln>
+        </p:spPr>
+        <p:style>
+          <a:lnRef idx="1">
+            <a:schemeClr val="accent1"/>
+          </a:lnRef>
+          <a:fillRef idx="0">
+            <a:schemeClr val="accent1"/>
+          </a:fillRef>
+          <a:effectRef idx="0">
+            <a:schemeClr val="accent1"/>
+          </a:effectRef>
+          <a:fontRef idx="minor">
+            <a:schemeClr val="tx1"/>
+          </a:fontRef>
+        </p:style>
+      </p:sp>
+      <p:sp>
+        <p:nvSpPr>
+          <p:cNvPr id="325" name="Freeform 325"/>
+          <p:cNvSpPr/>
+          <p:nvPr/>
+        </p:nvSpPr>
+        <p:spPr>
+          <a:xfrm>
+            <a:off x="4813300" y="1917700"/>
+            <a:ext cx="330200" cy="12700"/>
+          </a:xfrm>
+          <a:custGeom>
+            <a:avLst/>
+            <a:gdLst/>
+            <a:ahLst/>
+            <a:cxnLst/>
+            <a:rect l="l" t="t" r="r" b="b"/>
+            <a:pathLst>
+              <a:path w="100000" h="3846" fill="none">
                 <a:moveTo>
                   <a:pt x="0" y="0"/>
                 </a:moveTo>
@@ -3019,10 +3310,12 @@
               </a:path>
             </a:pathLst>
           </a:custGeom>
-          <a:ln w="38100">
+          <a:ln w="27940" cap="rnd">
             <a:solidFill>
-              <a:srgbClr val="9333EA"/>
+              <a:srgbClr val="64748B"/>
             </a:solidFill>
+            <a:prstDash val="solid"/>
+            <a:round/>
             <a:tailEnd type="triangle" w="med" len="med"/>
           </a:ln>
         </p:spPr>
@@ -3043,14 +3336,14 @@
       </p:sp>
       <p:sp>
         <p:nvSpPr>
-          <p:cNvPr id="266" name="Freeform 266"/>
+          <p:cNvPr id="326" name="Freeform 326"/>
           <p:cNvSpPr/>
           <p:nvPr/>
         </p:nvSpPr>
         <p:spPr>
           <a:xfrm>
-            <a:off x="6096000" y="3873500"/>
-            <a:ext cx="12700" cy="825500"/>
+            <a:off x="4813300" y="3251200"/>
+            <a:ext cx="330200" cy="12700"/>
           </a:xfrm>
           <a:custGeom>
             <a:avLst/>
@@ -3059,7 +3352,59 @@
             <a:cxnLst/>
             <a:rect l="l" t="t" r="r" b="b"/>
             <a:pathLst>
-              <a:path w="1538" h="100000" fill="none">
+              <a:path w="100000" h="3846" fill="none">
+                <a:moveTo>
+                  <a:pt x="0" y="0"/>
+                </a:moveTo>
+                <a:lnTo>
+                  <a:pt x="100000" y="0"/>
+                </a:lnTo>
+              </a:path>
+            </a:pathLst>
+          </a:custGeom>
+          <a:ln w="27940" cap="rnd">
+            <a:solidFill>
+              <a:srgbClr val="2563EB"/>
+            </a:solidFill>
+            <a:prstDash val="solid"/>
+            <a:round/>
+            <a:tailEnd type="triangle" w="med" len="med"/>
+          </a:ln>
+        </p:spPr>
+        <p:style>
+          <a:lnRef idx="1">
+            <a:schemeClr val="accent1"/>
+          </a:lnRef>
+          <a:fillRef idx="0">
+            <a:schemeClr val="accent1"/>
+          </a:fillRef>
+          <a:effectRef idx="0">
+            <a:schemeClr val="accent1"/>
+          </a:effectRef>
+          <a:fontRef idx="minor">
+            <a:schemeClr val="tx1"/>
+          </a:fontRef>
+        </p:style>
+      </p:sp>
+      <p:sp>
+        <p:nvSpPr>
+          <p:cNvPr id="327" name="Freeform 327"/>
+          <p:cNvSpPr/>
+          <p:nvPr/>
+        </p:nvSpPr>
+        <p:spPr>
+          <a:xfrm>
+            <a:off x="4038600" y="3746500"/>
+            <a:ext cx="12700" cy="393700"/>
+          </a:xfrm>
+          <a:custGeom>
+            <a:avLst/>
+            <a:gdLst/>
+            <a:ahLst/>
+            <a:cxnLst/>
+            <a:rect l="l" t="t" r="r" b="b"/>
+            <a:pathLst>
+              <a:path w="3226" h="100000" fill="none">
                 <a:moveTo>
                   <a:pt x="0" y="0"/>
                 </a:moveTo>
@@ -3069,10 +3414,12 @@
               </a:path>
             </a:pathLst>
           </a:custGeom>
-          <a:ln w="38100">
+          <a:ln w="27940" cap="rnd">
             <a:solidFill>
               <a:srgbClr val="2563EB"/>
             </a:solidFill>
+            <a:prstDash val="solid"/>
+            <a:round/>
             <a:tailEnd type="triangle" w="med" len="med"/>
           </a:ln>
         </p:spPr>
@@ -3093,14 +3440,14 @@
       </p:sp>
       <p:sp>
         <p:nvSpPr>
-          <p:cNvPr id="267" name="Freeform 267"/>
+          <p:cNvPr id="328" name="Freeform 328"/>
           <p:cNvSpPr/>
           <p:nvPr/>
         </p:nvSpPr>
         <p:spPr>
           <a:xfrm>
-            <a:off x="9779000" y="2794000"/>
-            <a:ext cx="317500" cy="12700"/>
+            <a:off x="4813300" y="4635500"/>
+            <a:ext cx="330200" cy="12700"/>
           </a:xfrm>
           <a:custGeom>
             <a:avLst/>
@@ -3109,7 +3456,7 @@
             <a:cxnLst/>
             <a:rect l="l" t="t" r="r" b="b"/>
             <a:pathLst>
-              <a:path w="100000" h="4000" fill="none">
+              <a:path w="100000" h="3846" fill="none">
                 <a:moveTo>
                   <a:pt x="0" y="0"/>
                 </a:moveTo>
@@ -3119,10 +3466,12 @@
               </a:path>
             </a:pathLst>
           </a:custGeom>
-          <a:ln w="38100">
+          <a:ln w="27940" cap="rnd">
             <a:solidFill>
-              <a:srgbClr val="9333EA"/>
+              <a:srgbClr val="2563EB"/>
             </a:solidFill>
+            <a:prstDash val="solid"/>
+            <a:round/>
             <a:tailEnd type="triangle" w="med" len="med"/>
           </a:ln>
         </p:spPr>
@@ -3143,14 +3492,14 @@
       </p:sp>
       <p:sp>
         <p:nvSpPr>
-          <p:cNvPr id="268" name="Freeform 268"/>
+          <p:cNvPr id="329" name="Freeform 329"/>
           <p:cNvSpPr/>
           <p:nvPr/>
         </p:nvSpPr>
         <p:spPr>
           <a:xfrm>
-            <a:off x="8001000" y="3810000"/>
-            <a:ext cx="2095500" cy="1651000"/>
+            <a:off x="6032500" y="5143500"/>
+            <a:ext cx="12700" cy="254000"/>
           </a:xfrm>
           <a:custGeom>
             <a:avLst/>
@@ -3159,15 +3508,565 @@
             <a:cxnLst/>
             <a:rect l="l" t="t" r="r" b="b"/>
             <a:pathLst>
-              <a:path w="100000" h="78788" fill="none">
+              <a:path w="5000" h="100000" fill="none">
                 <a:moveTo>
-                  <a:pt x="0" y="78788"/>
+                  <a:pt x="0" y="0"/>
                 </a:moveTo>
                 <a:lnTo>
-                  <a:pt x="30303" y="78788"/>
+                  <a:pt x="0" y="100000"/>
+                </a:lnTo>
+              </a:path>
+            </a:pathLst>
+          </a:custGeom>
+          <a:ln w="27940" cap="rnd">
+            <a:solidFill>
+              <a:srgbClr val="2563EB"/>
+            </a:solidFill>
+            <a:prstDash val="solid"/>
+            <a:round/>
+            <a:tailEnd type="triangle" w="med" len="med"/>
+          </a:ln>
+        </p:spPr>
+        <p:style>
+          <a:lnRef idx="1">
+            <a:schemeClr val="accent1"/>
+          </a:lnRef>
+          <a:fillRef idx="0">
+            <a:schemeClr val="accent1"/>
+          </a:fillRef>
+          <a:effectRef idx="0">
+            <a:schemeClr val="accent1"/>
+          </a:effectRef>
+          <a:fontRef idx="minor">
+            <a:schemeClr val="tx1"/>
+          </a:fontRef>
+        </p:style>
+      </p:sp>
+      <p:sp>
+        <p:nvSpPr>
+          <p:cNvPr id="330" name="Freeform 330"/>
+          <p:cNvSpPr/>
+          <p:nvPr/>
+        </p:nvSpPr>
+        <p:spPr>
+          <a:xfrm>
+            <a:off x="4813300" y="4635500"/>
+            <a:ext cx="330200" cy="1155700"/>
+          </a:xfrm>
+          <a:custGeom>
+            <a:avLst/>
+            <a:gdLst/>
+            <a:ahLst/>
+            <a:cxnLst/>
+            <a:rect l="l" t="t" r="r" b="b"/>
+            <a:pathLst>
+              <a:path w="28571" h="100000" fill="none">
+                <a:moveTo>
+                  <a:pt x="28571" y="0"/>
+                </a:moveTo>
+                <a:lnTo>
+                  <a:pt x="13187" y="0"/>
                 </a:lnTo>
                 <a:lnTo>
-                  <a:pt x="30303" y="0"/>
+                  <a:pt x="13187" y="100000"/>
+                </a:lnTo>
+                <a:lnTo>
+                  <a:pt x="0" y="100000"/>
+                </a:lnTo>
+              </a:path>
+            </a:pathLst>
+          </a:custGeom>
+          <a:ln w="27940" cap="rnd">
+            <a:solidFill>
+              <a:srgbClr val="9333EA"/>
+            </a:solidFill>
+            <a:prstDash val="solid"/>
+            <a:round/>
+            <a:tailEnd type="triangle" w="med" len="med"/>
+          </a:ln>
+        </p:spPr>
+        <p:style>
+          <a:lnRef idx="1">
+            <a:schemeClr val="accent1"/>
+          </a:lnRef>
+          <a:fillRef idx="0">
+            <a:schemeClr val="accent1"/>
+          </a:fillRef>
+          <a:effectRef idx="0">
+            <a:schemeClr val="accent1"/>
+          </a:effectRef>
+          <a:fontRef idx="minor">
+            <a:schemeClr val="tx1"/>
+          </a:fontRef>
+        </p:style>
+      </p:sp>
+      <p:sp>
+        <p:nvSpPr>
+          <p:cNvPr id="331" name="Freeform 331"/>
+          <p:cNvSpPr/>
+          <p:nvPr/>
+        </p:nvSpPr>
+        <p:spPr>
+          <a:xfrm>
+            <a:off x="6921500" y="2057400"/>
+            <a:ext cx="673100" cy="2578100"/>
+          </a:xfrm>
+          <a:custGeom>
+            <a:avLst/>
+            <a:gdLst/>
+            <a:ahLst/>
+            <a:cxnLst/>
+            <a:rect l="l" t="t" r="r" b="b"/>
+            <a:pathLst>
+              <a:path w="26108" h="100000" fill="none">
+                <a:moveTo>
+                  <a:pt x="0" y="100000"/>
+                </a:moveTo>
+                <a:lnTo>
+                  <a:pt x="9852" y="100000"/>
+                </a:lnTo>
+                <a:lnTo>
+                  <a:pt x="9852" y="0"/>
+                </a:lnTo>
+                <a:lnTo>
+                  <a:pt x="26108" y="0"/>
+                </a:lnTo>
+              </a:path>
+            </a:pathLst>
+          </a:custGeom>
+          <a:ln w="27940" cap="rnd">
+            <a:solidFill>
+              <a:srgbClr val="9333EA"/>
+            </a:solidFill>
+            <a:prstDash val="solid"/>
+            <a:round/>
+            <a:tailEnd type="triangle" w="med" len="med"/>
+          </a:ln>
+        </p:spPr>
+        <p:style>
+          <a:lnRef idx="1">
+            <a:schemeClr val="accent1"/>
+          </a:lnRef>
+          <a:fillRef idx="0">
+            <a:schemeClr val="accent1"/>
+          </a:fillRef>
+          <a:effectRef idx="0">
+            <a:schemeClr val="accent1"/>
+          </a:effectRef>
+          <a:fontRef idx="minor">
+            <a:schemeClr val="tx1"/>
+          </a:fontRef>
+        </p:style>
+      </p:sp>
+      <p:sp>
+        <p:nvSpPr>
+          <p:cNvPr id="332" name="Freeform 332"/>
+          <p:cNvSpPr/>
+          <p:nvPr/>
+        </p:nvSpPr>
+        <p:spPr>
+          <a:xfrm>
+            <a:off x="4813300" y="2781300"/>
+            <a:ext cx="2781300" cy="3009900"/>
+          </a:xfrm>
+          <a:custGeom>
+            <a:avLst/>
+            <a:gdLst/>
+            <a:ahLst/>
+            <a:cxnLst/>
+            <a:rect l="l" t="t" r="r" b="b"/>
+            <a:pathLst>
+              <a:path w="92405" h="100000" fill="none">
+                <a:moveTo>
+                  <a:pt x="92405" y="0"/>
+                </a:moveTo>
+                <a:lnTo>
+                  <a:pt x="75527" y="0"/>
+                </a:lnTo>
+                <a:lnTo>
+                  <a:pt x="75527" y="100000"/>
+                </a:lnTo>
+                <a:lnTo>
+                  <a:pt x="0" y="100000"/>
+                </a:lnTo>
+              </a:path>
+            </a:pathLst>
+          </a:custGeom>
+          <a:ln w="27940" cap="rnd">
+            <a:solidFill>
+              <a:srgbClr val="9333EA"/>
+            </a:solidFill>
+            <a:prstDash val="solid"/>
+            <a:round/>
+            <a:tailEnd type="triangle" w="med" len="med"/>
+          </a:ln>
+        </p:spPr>
+        <p:style>
+          <a:lnRef idx="1">
+            <a:schemeClr val="accent1"/>
+          </a:lnRef>
+          <a:fillRef idx="0">
+            <a:schemeClr val="accent1"/>
+          </a:fillRef>
+          <a:effectRef idx="0">
+            <a:schemeClr val="accent1"/>
+          </a:effectRef>
+          <a:fontRef idx="minor">
+            <a:schemeClr val="tx1"/>
+          </a:fontRef>
+        </p:style>
+      </p:sp>
+      <p:sp>
+        <p:nvSpPr>
+          <p:cNvPr id="333" name="Freeform 333"/>
+          <p:cNvSpPr/>
+          <p:nvPr/>
+        </p:nvSpPr>
+        <p:spPr>
+          <a:xfrm>
+            <a:off x="6921500" y="3492500"/>
+            <a:ext cx="673100" cy="2070100"/>
+          </a:xfrm>
+          <a:custGeom>
+            <a:avLst/>
+            <a:gdLst/>
+            <a:ahLst/>
+            <a:cxnLst/>
+            <a:rect l="l" t="t" r="r" b="b"/>
+            <a:pathLst>
+              <a:path w="32515" h="100000" fill="none">
+                <a:moveTo>
+                  <a:pt x="32515" y="0"/>
+                </a:moveTo>
+                <a:lnTo>
+                  <a:pt x="17791" y="0"/>
+                </a:lnTo>
+                <a:lnTo>
+                  <a:pt x="17791" y="100000"/>
+                </a:lnTo>
+                <a:lnTo>
+                  <a:pt x="0" y="100000"/>
+                </a:lnTo>
+              </a:path>
+            </a:pathLst>
+          </a:custGeom>
+          <a:ln w="27940" cap="rnd">
+            <a:solidFill>
+              <a:srgbClr val="16A34A"/>
+            </a:solidFill>
+            <a:prstDash val="solid"/>
+            <a:round/>
+            <a:tailEnd type="triangle" w="med" len="med"/>
+          </a:ln>
+        </p:spPr>
+        <p:style>
+          <a:lnRef idx="1">
+            <a:schemeClr val="accent1"/>
+          </a:lnRef>
+          <a:fillRef idx="0">
+            <a:schemeClr val="accent1"/>
+          </a:fillRef>
+          <a:effectRef idx="0">
+            <a:schemeClr val="accent1"/>
+          </a:effectRef>
+          <a:fontRef idx="minor">
+            <a:schemeClr val="tx1"/>
+          </a:fontRef>
+        </p:style>
+      </p:sp>
+      <p:sp>
+        <p:nvSpPr>
+          <p:cNvPr id="334" name="Freeform 334"/>
+          <p:cNvSpPr/>
+          <p:nvPr/>
+        </p:nvSpPr>
+        <p:spPr>
+          <a:xfrm>
+            <a:off x="6921500" y="3733800"/>
+            <a:ext cx="673100" cy="2209800"/>
+          </a:xfrm>
+          <a:custGeom>
+            <a:avLst/>
+            <a:gdLst/>
+            <a:ahLst/>
+            <a:cxnLst/>
+            <a:rect l="l" t="t" r="r" b="b"/>
+            <a:pathLst>
+              <a:path w="30460" h="100000" fill="none">
+                <a:moveTo>
+                  <a:pt x="0" y="100000"/>
+                </a:moveTo>
+                <a:lnTo>
+                  <a:pt x="21839" y="100000"/>
+                </a:lnTo>
+                <a:lnTo>
+                  <a:pt x="21839" y="0"/>
+                </a:lnTo>
+                <a:lnTo>
+                  <a:pt x="30460" y="0"/>
+                </a:lnTo>
+              </a:path>
+            </a:pathLst>
+          </a:custGeom>
+          <a:ln w="27940" cap="rnd">
+            <a:solidFill>
+              <a:srgbClr val="16A34A"/>
+            </a:solidFill>
+            <a:prstDash val="solid"/>
+            <a:round/>
+            <a:tailEnd type="triangle" w="med" len="med"/>
+          </a:ln>
+        </p:spPr>
+        <p:style>
+          <a:lnRef idx="1">
+            <a:schemeClr val="accent1"/>
+          </a:lnRef>
+          <a:fillRef idx="0">
+            <a:schemeClr val="accent1"/>
+          </a:fillRef>
+          <a:effectRef idx="0">
+            <a:schemeClr val="accent1"/>
+          </a:effectRef>
+          <a:fontRef idx="minor">
+            <a:schemeClr val="tx1"/>
+          </a:fontRef>
+        </p:style>
+      </p:sp>
+      <p:sp>
+        <p:nvSpPr>
+          <p:cNvPr id="335" name="Freeform 335"/>
+          <p:cNvSpPr/>
+          <p:nvPr/>
+        </p:nvSpPr>
+        <p:spPr>
+          <a:xfrm>
+            <a:off x="8572500" y="2057400"/>
+            <a:ext cx="469900" cy="12700"/>
+          </a:xfrm>
+          <a:custGeom>
+            <a:avLst/>
+            <a:gdLst/>
+            <a:ahLst/>
+            <a:cxnLst/>
+            <a:rect l="l" t="t" r="r" b="b"/>
+            <a:pathLst>
+              <a:path w="100000" h="2703" fill="none">
+                <a:moveTo>
+                  <a:pt x="0" y="0"/>
+                </a:moveTo>
+                <a:lnTo>
+                  <a:pt x="100000" y="0"/>
+                </a:lnTo>
+              </a:path>
+            </a:pathLst>
+          </a:custGeom>
+          <a:ln w="27940" cap="rnd">
+            <a:solidFill>
+              <a:srgbClr val="9333EA"/>
+            </a:solidFill>
+            <a:prstDash val="solid"/>
+            <a:round/>
+            <a:tailEnd type="triangle" w="med" len="med"/>
+          </a:ln>
+        </p:spPr>
+        <p:style>
+          <a:lnRef idx="1">
+            <a:schemeClr val="accent1"/>
+          </a:lnRef>
+          <a:fillRef idx="0">
+            <a:schemeClr val="accent1"/>
+          </a:fillRef>
+          <a:effectRef idx="0">
+            <a:schemeClr val="accent1"/>
+          </a:effectRef>
+          <a:fontRef idx="minor">
+            <a:schemeClr val="tx1"/>
+          </a:fontRef>
+        </p:style>
+      </p:sp>
+      <p:sp>
+        <p:nvSpPr>
+          <p:cNvPr id="336" name="Freeform 336"/>
+          <p:cNvSpPr/>
+          <p:nvPr/>
+        </p:nvSpPr>
+        <p:spPr>
+          <a:xfrm>
+            <a:off x="8572500" y="2590800"/>
+            <a:ext cx="469900" cy="12700"/>
+          </a:xfrm>
+          <a:custGeom>
+            <a:avLst/>
+            <a:gdLst/>
+            <a:ahLst/>
+            <a:cxnLst/>
+            <a:rect l="l" t="t" r="r" b="b"/>
+            <a:pathLst>
+              <a:path w="100000" h="2703" fill="none">
+                <a:moveTo>
+                  <a:pt x="100000" y="0"/>
+                </a:moveTo>
+                <a:lnTo>
+                  <a:pt x="0" y="0"/>
+                </a:lnTo>
+              </a:path>
+            </a:pathLst>
+          </a:custGeom>
+          <a:ln w="27940" cap="rnd">
+            <a:solidFill>
+              <a:srgbClr val="9333EA"/>
+            </a:solidFill>
+            <a:prstDash val="solid"/>
+            <a:round/>
+            <a:tailEnd type="triangle" w="med" len="med"/>
+          </a:ln>
+        </p:spPr>
+        <p:style>
+          <a:lnRef idx="1">
+            <a:schemeClr val="accent1"/>
+          </a:lnRef>
+          <a:fillRef idx="0">
+            <a:schemeClr val="accent1"/>
+          </a:fillRef>
+          <a:effectRef idx="0">
+            <a:schemeClr val="accent1"/>
+          </a:effectRef>
+          <a:fontRef idx="minor">
+            <a:schemeClr val="tx1"/>
+          </a:fontRef>
+        </p:style>
+      </p:sp>
+      <p:sp>
+        <p:nvSpPr>
+          <p:cNvPr id="337" name="Freeform 337"/>
+          <p:cNvSpPr/>
+          <p:nvPr/>
+        </p:nvSpPr>
+        <p:spPr>
+          <a:xfrm>
+            <a:off x="8572500" y="3429000"/>
+            <a:ext cx="469900" cy="12700"/>
+          </a:xfrm>
+          <a:custGeom>
+            <a:avLst/>
+            <a:gdLst/>
+            <a:ahLst/>
+            <a:cxnLst/>
+            <a:rect l="l" t="t" r="r" b="b"/>
+            <a:pathLst>
+              <a:path w="100000" h="2703" fill="none">
+                <a:moveTo>
+                  <a:pt x="100000" y="0"/>
+                </a:moveTo>
+                <a:lnTo>
+                  <a:pt x="0" y="0"/>
+                </a:lnTo>
+              </a:path>
+            </a:pathLst>
+          </a:custGeom>
+          <a:ln w="27940" cap="rnd">
+            <a:solidFill>
+              <a:srgbClr val="16A34A"/>
+            </a:solidFill>
+            <a:prstDash val="solid"/>
+            <a:round/>
+            <a:tailEnd type="triangle" w="med" len="med"/>
+          </a:ln>
+        </p:spPr>
+        <p:style>
+          <a:lnRef idx="1">
+            <a:schemeClr val="accent1"/>
+          </a:lnRef>
+          <a:fillRef idx="0">
+            <a:schemeClr val="accent1"/>
+          </a:fillRef>
+          <a:effectRef idx="0">
+            <a:schemeClr val="accent1"/>
+          </a:effectRef>
+          <a:fontRef idx="minor">
+            <a:schemeClr val="tx1"/>
+          </a:fontRef>
+        </p:style>
+      </p:sp>
+      <p:sp>
+        <p:nvSpPr>
+          <p:cNvPr id="338" name="Freeform 338"/>
+          <p:cNvSpPr/>
+          <p:nvPr/>
+        </p:nvSpPr>
+        <p:spPr>
+          <a:xfrm>
+            <a:off x="8572500" y="3733800"/>
+            <a:ext cx="469900" cy="12700"/>
+          </a:xfrm>
+          <a:custGeom>
+            <a:avLst/>
+            <a:gdLst/>
+            <a:ahLst/>
+            <a:cxnLst/>
+            <a:rect l="l" t="t" r="r" b="b"/>
+            <a:pathLst>
+              <a:path w="100000" h="2703" fill="none">
+                <a:moveTo>
+                  <a:pt x="0" y="0"/>
+                </a:moveTo>
+                <a:lnTo>
+                  <a:pt x="100000" y="0"/>
+                </a:lnTo>
+              </a:path>
+            </a:pathLst>
+          </a:custGeom>
+          <a:ln w="27940" cap="rnd">
+            <a:solidFill>
+              <a:srgbClr val="16A34A"/>
+            </a:solidFill>
+            <a:prstDash val="solid"/>
+            <a:round/>
+            <a:tailEnd type="triangle" w="med" len="med"/>
+          </a:ln>
+        </p:spPr>
+        <p:style>
+          <a:lnRef idx="1">
+            <a:schemeClr val="accent1"/>
+          </a:lnRef>
+          <a:fillRef idx="0">
+            <a:schemeClr val="accent1"/>
+          </a:fillRef>
+          <a:effectRef idx="0">
+            <a:schemeClr val="accent1"/>
+          </a:effectRef>
+          <a:fontRef idx="minor">
+            <a:schemeClr val="tx1"/>
+          </a:fontRef>
+        </p:style>
+      </p:sp>
+      <p:sp>
+        <p:nvSpPr>
+          <p:cNvPr id="339" name="Freeform 339"/>
+          <p:cNvSpPr/>
+          <p:nvPr/>
+        </p:nvSpPr>
+        <p:spPr>
+          <a:xfrm>
+            <a:off x="6921500" y="5651500"/>
+            <a:ext cx="673100" cy="12700"/>
+          </a:xfrm>
+          <a:custGeom>
+            <a:avLst/>
+            <a:gdLst/>
+            <a:ahLst/>
+            <a:cxnLst/>
+            <a:rect l="l" t="t" r="r" b="b"/>
+            <a:pathLst>
+              <a:path w="100000" h="1887" fill="none">
+                <a:moveTo>
+                  <a:pt x="0" y="0"/>
+                </a:moveTo>
+                <a:lnTo>
+                  <a:pt x="84906" y="0"/>
+                </a:lnTo>
+                <a:lnTo>
+                  <a:pt x="84906" y="0"/>
                 </a:lnTo>
                 <a:lnTo>
                   <a:pt x="100000" y="0"/>
@@ -3175,11 +4074,12 @@
               </a:path>
             </a:pathLst>
           </a:custGeom>
-          <a:ln w="50800">
+          <a:ln w="27940" cap="rnd">
             <a:solidFill>
-              <a:srgbClr val="16A34A"/>
+              <a:srgbClr val="64748B"/>
             </a:solidFill>
-            <a:headEnd type="triangle" w="med" len="med"/>
+            <a:prstDash val="solid"/>
+            <a:round/>
             <a:tailEnd type="triangle" w="med" len="med"/>
           </a:ln>
         </p:spPr>
@@ -3200,14 +4100,14 @@
       </p:sp>
       <p:sp>
         <p:nvSpPr>
-          <p:cNvPr id="269" name="Freeform 269"/>
+          <p:cNvPr id="340" name="Freeform 340"/>
           <p:cNvSpPr/>
           <p:nvPr/>
         </p:nvSpPr>
         <p:spPr>
           <a:xfrm>
-            <a:off x="10477500" y="4064000"/>
-            <a:ext cx="12700" cy="635000"/>
+            <a:off x="8572500" y="5651500"/>
+            <a:ext cx="469900" cy="12700"/>
           </a:xfrm>
           <a:custGeom>
             <a:avLst/>
@@ -3216,7 +4116,59 @@
             <a:cxnLst/>
             <a:rect l="l" t="t" r="r" b="b"/>
             <a:pathLst>
-              <a:path w="2000" h="100000" fill="none">
+              <a:path w="100000" h="2703" fill="none">
+                <a:moveTo>
+                  <a:pt x="0" y="0"/>
+                </a:moveTo>
+                <a:lnTo>
+                  <a:pt x="100000" y="0"/>
+                </a:lnTo>
+              </a:path>
+            </a:pathLst>
+          </a:custGeom>
+          <a:ln w="27940" cap="rnd">
+            <a:solidFill>
+              <a:srgbClr val="64748B"/>
+            </a:solidFill>
+            <a:prstDash val="solid"/>
+            <a:round/>
+            <a:tailEnd type="triangle" w="med" len="med"/>
+          </a:ln>
+        </p:spPr>
+        <p:style>
+          <a:lnRef idx="1">
+            <a:schemeClr val="accent1"/>
+          </a:lnRef>
+          <a:fillRef idx="0">
+            <a:schemeClr val="accent1"/>
+          </a:fillRef>
+          <a:effectRef idx="0">
+            <a:schemeClr val="accent1"/>
+          </a:effectRef>
+          <a:fontRef idx="minor">
+            <a:schemeClr val="tx1"/>
+          </a:fontRef>
+        </p:style>
+      </p:sp>
+      <p:sp>
+        <p:nvSpPr>
+          <p:cNvPr id="341" name="Freeform 341"/>
+          <p:cNvSpPr/>
+          <p:nvPr/>
+        </p:nvSpPr>
+        <p:spPr>
+          <a:xfrm>
+            <a:off x="10185400" y="3987800"/>
+            <a:ext cx="12700" cy="1181100"/>
+          </a:xfrm>
+          <a:custGeom>
+            <a:avLst/>
+            <a:gdLst/>
+            <a:ahLst/>
+            <a:cxnLst/>
+            <a:rect l="l" t="t" r="r" b="b"/>
+            <a:pathLst>
+              <a:path w="1075" h="100000" fill="none">
                 <a:moveTo>
                   <a:pt x="0" y="100000"/>
                 </a:moveTo>
@@ -3226,10 +4178,12 @@
               </a:path>
             </a:pathLst>
           </a:custGeom>
-          <a:ln w="25400">
+          <a:ln w="27940" cap="rnd">
             <a:solidFill>
               <a:srgbClr val="64748B"/>
             </a:solidFill>
+            <a:prstDash val="solid"/>
+            <a:round/>
             <a:tailEnd type="triangle" w="med" len="med"/>
           </a:ln>
         </p:spPr>
@@ -3250,24 +4204,24 @@
       </p:sp>
       <p:sp>
         <p:nvSpPr>
-          <p:cNvPr id="270" name="Rectangle 11"/>
+          <p:cNvPr id="342" name="Rectangle 30"/>
           <p:cNvSpPr/>
           <p:nvPr/>
         </p:nvSpPr>
         <p:spPr>
           <a:xfrm>
-            <a:off x="4953000" y="1143000"/>
-            <a:ext cx="2286000" cy="584200"/>
+            <a:off x="635000" y="1600200"/>
+            <a:ext cx="2082800" cy="1473200"/>
           </a:xfrm>
           <a:prstGeom prst="roundRect">
             <a:avLst/>
           </a:prstGeom>
           <a:solidFill>
-            <a:srgbClr val="F1F5F9"/>
+            <a:srgbClr val="DBEAFE"/>
           </a:solidFill>
           <a:ln w="25400">
             <a:solidFill>
-              <a:srgbClr val="64748B"/>
+              <a:srgbClr val="2563EB"/>
             </a:solidFill>
           </a:ln>
         </p:spPr>
@@ -3288,45 +4242,45 @@
           </a:fontRef>
         </p:style>
         <p:txBody>
-          <a:bodyPr/>
+          <a:bodyPr anchor="ctr"/>
           <a:lstStyle/>
           <a:p/>
         </p:txBody>
       </p:sp>
       <p:sp>
         <p:nvSpPr>
-          <p:cNvPr id="271" name="TextBox 12"/>
+          <p:cNvPr id="343" name="TextBox 31"/>
           <p:cNvSpPr txBox="1"/>
           <p:nvPr/>
         </p:nvSpPr>
         <p:spPr>
           <a:xfrm>
-            <a:off x="5080000" y="1219200"/>
-            <a:ext cx="2032000" cy="275838"/>
-          </a:xfrm>
-          <a:prstGeom prst="rect">
-            <a:avLst/>
-          </a:prstGeom>
-        </p:spPr>
-        <p:txBody>
-          <a:bodyPr wrap="square" anchor="ctr">
-            <a:spAutoFit/>
+            <a:off x="800100" y="1765300"/>
+            <a:ext cx="1752600" cy="457200"/>
+          </a:xfrm>
+          <a:prstGeom prst="rect">
+            <a:avLst/>
+          </a:prstGeom>
+        </p:spPr>
+        <p:txBody>
+          <a:bodyPr wrap="square" lIns="0" tIns="0" rIns="0" bIns="0" anchor="ctr">
+            <a:normAutofit fontScale="100000"/>
           </a:bodyPr>
           <a:lstStyle/>
           <a:p>
             <a:pPr algn="ctr"/>
             <a:r>
-              <a:rPr sz="1200" b="1">
-                <a:solidFill>
-                  <a:srgbClr val="334155"/>
+              <a:rPr sz="1500" b="1">
+                <a:solidFill>
+                  <a:srgbClr val="1E3A8A"/>
                 </a:solidFill>
                 <a:latin typeface="Inter"/>
               </a:rPr>
-              <a:t>CLOCK + RESET</a:t>
+              <a:t>5-STAGE RV32I CPU</a:t>
             </a:r>
-            <a:endParaRPr sz="1200" b="1">
+            <a:endParaRPr sz="1500" b="1">
               <a:solidFill>
-                <a:srgbClr val="334155"/>
+                <a:srgbClr val="1E3A8A"/>
               </a:solidFill>
               <a:latin typeface="Inter"/>
             </a:endParaRPr>
@@ -3335,117 +4289,74 @@
       </p:sp>
       <p:sp>
         <p:nvSpPr>
-          <p:cNvPr id="272" name="TextBox 13"/>
+          <p:cNvPr id="344" name="TextBox 32"/>
           <p:cNvSpPr txBox="1"/>
           <p:nvPr/>
         </p:nvSpPr>
         <p:spPr>
           <a:xfrm>
-            <a:off x="5080000" y="1460500"/>
-            <a:ext cx="2032000" cy="229739"/>
-          </a:xfrm>
-          <a:prstGeom prst="rect">
-            <a:avLst/>
-          </a:prstGeom>
-        </p:spPr>
-        <p:txBody>
-          <a:bodyPr wrap="square" anchor="ctr">
-            <a:spAutoFit/>
+            <a:off x="800100" y="2171700"/>
+            <a:ext cx="1752600" cy="480060"/>
+          </a:xfrm>
+          <a:prstGeom prst="rect">
+            <a:avLst/>
+          </a:prstGeom>
+        </p:spPr>
+        <p:txBody>
+          <a:bodyPr wrap="square" lIns="0" tIns="0" rIns="0" bIns="0" anchor="ctr">
+            <a:normAutofit fontScale="100000"/>
           </a:bodyPr>
           <a:lstStyle/>
           <a:p>
             <a:pPr algn="ctr"/>
             <a:r>
-              <a:rPr sz="900">
-                <a:solidFill>
-                  <a:srgbClr val="64748B"/>
+              <a:rPr sz="1050" b="0">
+                <a:solidFill>
+                  <a:srgbClr val="1E3A8A"/>
                 </a:solidFill>
                 <a:latin typeface="Inter"/>
               </a:rPr>
-              <a:t>Single shared domain</a:t>
+              <a:t>Forwarding + interlocks</a:t>
             </a:r>
-            <a:endParaRPr sz="900">
+            <a:endParaRPr sz="1050" b="0">
               <a:solidFill>
-                <a:srgbClr val="64748B"/>
+                <a:srgbClr val="1E3A8A"/>
               </a:solidFill>
               <a:latin typeface="Inter"/>
             </a:endParaRPr>
           </a:p>
-        </p:txBody>
-      </p:sp>
-      <p:sp>
-        <p:nvSpPr>
-          <p:cNvPr id="273" name="TextBox 14"/>
-          <p:cNvSpPr txBox="1"/>
-          <p:nvPr/>
-        </p:nvSpPr>
-        <p:spPr>
-          <a:xfrm>
-            <a:off x="635000" y="1905000"/>
-            <a:ext cx="1270000" cy="245105"/>
-          </a:xfrm>
-          <a:prstGeom prst="rect">
-            <a:avLst/>
-          </a:prstGeom>
-        </p:spPr>
-        <p:txBody>
-          <a:bodyPr wrap="square">
-            <a:spAutoFit/>
-          </a:bodyPr>
-          <a:lstStyle/>
-          <a:p>
+          <a:p>
+            <a:pPr algn="ctr"/>
             <a:r>
-              <a:rPr sz="1000" b="1">
-                <a:solidFill>
-                  <a:srgbClr val="94A3B8"/>
+              <a:rPr sz="1050" b="0">
+                <a:solidFill>
+                  <a:srgbClr val="1E3A8A"/>
                 </a:solidFill>
                 <a:latin typeface="Inter"/>
               </a:rPr>
-              <a:t>CPU SIDE</a:t>
+              <a:t>Retirement trace</a:t>
             </a:r>
-            <a:endParaRPr sz="1000" b="1">
+            <a:endParaRPr sz="1050" b="0">
               <a:solidFill>
-                <a:srgbClr val="94A3B8"/>
+                <a:srgbClr val="1E3A8A"/>
               </a:solidFill>
               <a:latin typeface="Inter"/>
             </a:endParaRPr>
           </a:p>
-        </p:txBody>
-      </p:sp>
-      <p:sp>
-        <p:nvSpPr>
-          <p:cNvPr id="274" name="TextBox 15"/>
-          <p:cNvSpPr txBox="1"/>
-          <p:nvPr/>
-        </p:nvSpPr>
-        <p:spPr>
-          <a:xfrm>
-            <a:off x="10731500" y="1651000"/>
-            <a:ext cx="1270000" cy="245105"/>
-          </a:xfrm>
-          <a:prstGeom prst="rect">
-            <a:avLst/>
-          </a:prstGeom>
-        </p:spPr>
-        <p:txBody>
-          <a:bodyPr wrap="square">
-            <a:spAutoFit/>
-          </a:bodyPr>
-          <a:lstStyle/>
-          <a:p>
-            <a:pPr algn="r"/>
+          <a:p>
+            <a:pPr algn="ctr"/>
             <a:r>
-              <a:rPr sz="1000" b="1">
-                <a:solidFill>
-                  <a:srgbClr val="94A3B8"/>
+              <a:rPr sz="1050" b="0">
+                <a:solidFill>
+                  <a:srgbClr val="1E3A8A"/>
                 </a:solidFill>
                 <a:latin typeface="Inter"/>
               </a:rPr>
-              <a:t>GPU SIDE</a:t>
+              <a:t>Fail-stop bus faults</a:t>
             </a:r>
-            <a:endParaRPr sz="1000" b="1">
+            <a:endParaRPr sz="1050" b="0">
               <a:solidFill>
-                <a:srgbClr val="94A3B8"/>
+                <a:srgbClr val="1E3A8A"/>
               </a:solidFill>
               <a:latin typeface="Inter"/>
             </a:endParaRPr>
@@ -3454,24 +4365,24 @@
       </p:sp>
       <p:sp>
         <p:nvSpPr>
-          <p:cNvPr id="275" name="Rectangle 16"/>
+          <p:cNvPr id="345" name="Rectangle 33"/>
           <p:cNvSpPr/>
           <p:nvPr/>
         </p:nvSpPr>
         <p:spPr>
           <a:xfrm>
-            <a:off x="571500" y="2286000"/>
-            <a:ext cx="3175000" cy="1778000"/>
+            <a:off x="3200400" y="1600200"/>
+            <a:ext cx="1612900" cy="660400"/>
           </a:xfrm>
           <a:prstGeom prst="roundRect">
             <a:avLst/>
           </a:prstGeom>
           <a:solidFill>
-            <a:srgbClr val="DBEAFE"/>
+            <a:srgbClr val="EFF6FF"/>
           </a:solidFill>
-          <a:ln w="31750">
+          <a:ln w="19050">
             <a:solidFill>
-              <a:srgbClr val="2563EB"/>
+              <a:srgbClr val="60A5FA"/>
             </a:solidFill>
           </a:ln>
         </p:spPr>
@@ -3492,45 +4403,45 @@
           </a:fontRef>
         </p:style>
         <p:txBody>
-          <a:bodyPr/>
+          <a:bodyPr anchor="ctr"/>
           <a:lstStyle/>
           <a:p/>
         </p:txBody>
       </p:sp>
       <p:sp>
         <p:nvSpPr>
-          <p:cNvPr id="276" name="TextBox 17"/>
+          <p:cNvPr id="346" name="TextBox 34"/>
           <p:cNvSpPr txBox="1"/>
           <p:nvPr/>
         </p:nvSpPr>
         <p:spPr>
           <a:xfrm>
-            <a:off x="762000" y="2463800"/>
-            <a:ext cx="2794000" cy="352671"/>
-          </a:xfrm>
-          <a:prstGeom prst="rect">
-            <a:avLst/>
-          </a:prstGeom>
-        </p:spPr>
-        <p:txBody>
-          <a:bodyPr wrap="square" anchor="ctr">
-            <a:spAutoFit/>
+            <a:off x="3340100" y="1689100"/>
+            <a:ext cx="1333500" cy="182880"/>
+          </a:xfrm>
+          <a:prstGeom prst="rect">
+            <a:avLst/>
+          </a:prstGeom>
+        </p:spPr>
+        <p:txBody>
+          <a:bodyPr wrap="square" lIns="0" tIns="0" rIns="0" bIns="0" anchor="ctr">
+            <a:normAutofit fontScale="100000"/>
           </a:bodyPr>
           <a:lstStyle/>
           <a:p>
             <a:pPr algn="ctr"/>
             <a:r>
-              <a:rPr sz="1700" b="1">
-                <a:solidFill>
-                  <a:srgbClr val="1E3A8A"/>
+              <a:rPr sz="1200" b="1">
+                <a:solidFill>
+                  <a:srgbClr val="1D4ED8"/>
                 </a:solidFill>
                 <a:latin typeface="Inter"/>
               </a:rPr>
-              <a:t>RISC-V CPU</a:t>
+              <a:t>I-CACHE</a:t>
             </a:r>
-            <a:endParaRPr sz="1700" b="1">
+            <a:endParaRPr sz="1200" b="1">
               <a:solidFill>
-                <a:srgbClr val="1E3A8A"/>
+                <a:srgbClr val="1D4ED8"/>
               </a:solidFill>
               <a:latin typeface="Inter"/>
             </a:endParaRPr>
@@ -3539,118 +4450,64 @@
       </p:sp>
       <p:sp>
         <p:nvSpPr>
-          <p:cNvPr id="277" name="TextBox 18"/>
+          <p:cNvPr id="347" name="TextBox 35"/>
           <p:cNvSpPr txBox="1"/>
           <p:nvPr/>
         </p:nvSpPr>
         <p:spPr>
           <a:xfrm>
-            <a:off x="762000" y="2844800"/>
-            <a:ext cx="2794000" cy="798299"/>
-          </a:xfrm>
-          <a:prstGeom prst="rect">
-            <a:avLst/>
-          </a:prstGeom>
-        </p:spPr>
-        <p:txBody>
-          <a:bodyPr wrap="square" anchor="ctr">
-            <a:spAutoFit/>
+            <a:off x="3340100" y="1943100"/>
+            <a:ext cx="1333500" cy="129540"/>
+          </a:xfrm>
+          <a:prstGeom prst="rect">
+            <a:avLst/>
+          </a:prstGeom>
+        </p:spPr>
+        <p:txBody>
+          <a:bodyPr wrap="square" lIns="0" tIns="0" rIns="0" bIns="0" anchor="ctr">
+            <a:normAutofit fontScale="100000"/>
           </a:bodyPr>
           <a:lstStyle/>
           <a:p>
             <a:pPr algn="ctr"/>
             <a:r>
-              <a:rPr sz="1150">
-                <a:solidFill>
-                  <a:srgbClr val="1E3A8A"/>
+              <a:rPr sz="850" b="0">
+                <a:solidFill>
+                  <a:srgbClr val="475569"/>
                 </a:solidFill>
                 <a:latin typeface="Inter"/>
               </a:rPr>
-              <a:t>Multi-cycle RV32I</a:t>
+              <a:t>blocking • direct map</a:t>
             </a:r>
-            <a:endParaRPr sz="1150">
+            <a:endParaRPr sz="850" b="0">
               <a:solidFill>
-                <a:srgbClr val="1E3A8A"/>
+                <a:srgbClr val="475569"/>
               </a:solidFill>
               <a:latin typeface="Inter"/>
             </a:endParaRPr>
           </a:p>
-          <a:p>
-            <a:pPr algn="ctr"/>
-            <a:r>
-              <a:rPr sz="1150">
-                <a:solidFill>
-                  <a:srgbClr val="1E3A8A"/>
-                </a:solidFill>
-                <a:latin typeface="Inter"/>
-              </a:rPr>
-              <a:t>Private instruction TCM</a:t>
-            </a:r>
-            <a:endParaRPr sz="1150">
-              <a:solidFill>
-                <a:srgbClr val="1E3A8A"/>
-              </a:solidFill>
-              <a:latin typeface="Inter"/>
-            </a:endParaRPr>
-          </a:p>
-          <a:p>
-            <a:pPr algn="ctr"/>
-            <a:r>
-              <a:rPr sz="1150">
-                <a:solidFill>
-                  <a:srgbClr val="1E3A8A"/>
-                </a:solidFill>
-                <a:latin typeface="Inter"/>
-              </a:rPr>
-              <a:t>ADDI | LW | SW</a:t>
-            </a:r>
-            <a:endParaRPr sz="1150">
-              <a:solidFill>
-                <a:srgbClr val="1E3A8A"/>
-              </a:solidFill>
-              <a:latin typeface="Inter"/>
-            </a:endParaRPr>
-          </a:p>
-          <a:p>
-            <a:pPr algn="ctr"/>
-            <a:r>
-              <a:rPr sz="1150">
-                <a:solidFill>
-                  <a:srgbClr val="1E3A8A"/>
-                </a:solidFill>
-                <a:latin typeface="Inter"/>
-              </a:rPr>
-              <a:t>BEQ | BNE | JAL</a:t>
-            </a:r>
-            <a:endParaRPr sz="1150">
-              <a:solidFill>
-                <a:srgbClr val="1E3A8A"/>
-              </a:solidFill>
-              <a:latin typeface="Inter"/>
-            </a:endParaRPr>
-          </a:p>
-        </p:txBody>
-      </p:sp>
-      <p:sp>
-        <p:nvSpPr>
-          <p:cNvPr id="278" name="Rectangle 19"/>
+        </p:txBody>
+      </p:sp>
+      <p:sp>
+        <p:nvSpPr>
+          <p:cNvPr id="348" name="Rectangle 36"/>
           <p:cNvSpPr/>
           <p:nvPr/>
         </p:nvSpPr>
         <p:spPr>
           <a:xfrm>
-            <a:off x="4635500" y="2476500"/>
-            <a:ext cx="2921000" cy="1397000"/>
+            <a:off x="5143500" y="1600200"/>
+            <a:ext cx="1778000" cy="660400"/>
           </a:xfrm>
           <a:prstGeom prst="roundRect">
             <a:avLst/>
           </a:prstGeom>
           <a:solidFill>
-            <a:srgbClr val="FEF3C7"/>
+            <a:srgbClr val="F1F5F9"/>
           </a:solidFill>
-          <a:ln w="31750">
+          <a:ln w="17780">
             <a:solidFill>
-              <a:srgbClr val="D97706"/>
+              <a:srgbClr val="94A3B8"/>
             </a:solidFill>
           </a:ln>
         </p:spPr>
@@ -3671,45 +4528,45 @@
           </a:fontRef>
         </p:style>
         <p:txBody>
-          <a:bodyPr/>
+          <a:bodyPr anchor="ctr"/>
           <a:lstStyle/>
           <a:p/>
         </p:txBody>
       </p:sp>
       <p:sp>
         <p:nvSpPr>
-          <p:cNvPr id="279" name="TextBox 20"/>
+          <p:cNvPr id="349" name="TextBox 37"/>
           <p:cNvSpPr txBox="1"/>
           <p:nvPr/>
         </p:nvSpPr>
         <p:spPr>
           <a:xfrm>
-            <a:off x="4826000" y="2641600"/>
-            <a:ext cx="2540000" cy="337304"/>
-          </a:xfrm>
-          <a:prstGeom prst="rect">
-            <a:avLst/>
-          </a:prstGeom>
-        </p:spPr>
-        <p:txBody>
-          <a:bodyPr wrap="square" anchor="ctr">
-            <a:spAutoFit/>
+            <a:off x="5245100" y="1689100"/>
+            <a:ext cx="1574800" cy="140208"/>
+          </a:xfrm>
+          <a:prstGeom prst="rect">
+            <a:avLst/>
+          </a:prstGeom>
+        </p:spPr>
+        <p:txBody>
+          <a:bodyPr wrap="square" lIns="0" tIns="0" rIns="0" bIns="0" anchor="ctr">
+            <a:normAutofit fontScale="100000"/>
           </a:bodyPr>
           <a:lstStyle/>
           <a:p>
             <a:pPr algn="ctr"/>
             <a:r>
-              <a:rPr sz="1600" b="1">
-                <a:solidFill>
-                  <a:srgbClr val="78350F"/>
+              <a:rPr sz="920" b="1">
+                <a:solidFill>
+                  <a:srgbClr val="334155"/>
                 </a:solidFill>
                 <a:latin typeface="Inter"/>
               </a:rPr>
-              <a:t>AXI4-Lite Interconnect</a:t>
+              <a:t>CPU PROGRAM MEMORY</a:t>
             </a:r>
-            <a:endParaRPr sz="1600" b="1">
+            <a:endParaRPr sz="920" b="1">
               <a:solidFill>
-                <a:srgbClr val="78350F"/>
+                <a:srgbClr val="334155"/>
               </a:solidFill>
               <a:latin typeface="Inter"/>
             </a:endParaRPr>
@@ -3718,100 +4575,64 @@
       </p:sp>
       <p:sp>
         <p:nvSpPr>
-          <p:cNvPr id="280" name="TextBox 21"/>
+          <p:cNvPr id="350" name="TextBox 38"/>
           <p:cNvSpPr txBox="1"/>
           <p:nvPr/>
         </p:nvSpPr>
         <p:spPr>
           <a:xfrm>
-            <a:off x="4826000" y="3048000"/>
-            <a:ext cx="2540000" cy="621584"/>
-          </a:xfrm>
-          <a:prstGeom prst="rect">
-            <a:avLst/>
-          </a:prstGeom>
-        </p:spPr>
-        <p:txBody>
-          <a:bodyPr wrap="square" anchor="ctr">
-            <a:spAutoFit/>
+            <a:off x="5270500" y="1955800"/>
+            <a:ext cx="1524000" cy="126492"/>
+          </a:xfrm>
+          <a:prstGeom prst="rect">
+            <a:avLst/>
+          </a:prstGeom>
+        </p:spPr>
+        <p:txBody>
+          <a:bodyPr wrap="square" lIns="0" tIns="0" rIns="0" bIns="0" anchor="ctr">
+            <a:normAutofit fontScale="100000"/>
           </a:bodyPr>
           <a:lstStyle/>
           <a:p>
             <a:pPr algn="ctr"/>
             <a:r>
-              <a:rPr sz="1150">
-                <a:solidFill>
-                  <a:srgbClr val="78350F"/>
+              <a:rPr sz="830" b="0">
+                <a:solidFill>
+                  <a:srgbClr val="64748B"/>
                 </a:solidFill>
                 <a:latin typeface="Inter"/>
               </a:rPr>
-              <a:t>32-bit control + data</a:t>
+              <a:t>4 KiB private fetch</a:t>
             </a:r>
-            <a:endParaRPr sz="1150">
+            <a:endParaRPr sz="830" b="0">
               <a:solidFill>
-                <a:srgbClr val="78350F"/>
+                <a:srgbClr val="64748B"/>
               </a:solidFill>
               <a:latin typeface="Inter"/>
             </a:endParaRPr>
           </a:p>
-          <a:p>
-            <a:pPr algn="ctr"/>
-            <a:r>
-              <a:rPr sz="1150">
-                <a:solidFill>
-                  <a:srgbClr val="78350F"/>
-                </a:solidFill>
-                <a:latin typeface="Inter"/>
-              </a:rPr>
-              <a:t>Round-robin arbitration</a:t>
-            </a:r>
-            <a:endParaRPr sz="1150">
-              <a:solidFill>
-                <a:srgbClr val="78350F"/>
-              </a:solidFill>
-              <a:latin typeface="Inter"/>
-            </a:endParaRPr>
-          </a:p>
-          <a:p>
-            <a:pPr algn="ctr"/>
-            <a:r>
-              <a:rPr sz="1150">
-                <a:solidFill>
-                  <a:srgbClr val="78350F"/>
-                </a:solidFill>
-                <a:latin typeface="Inter"/>
-              </a:rPr>
-              <a:t>Address decode</a:t>
-            </a:r>
-            <a:endParaRPr sz="1150">
-              <a:solidFill>
-                <a:srgbClr val="78350F"/>
-              </a:solidFill>
-              <a:latin typeface="Inter"/>
-            </a:endParaRPr>
-          </a:p>
-        </p:txBody>
-      </p:sp>
-      <p:sp>
-        <p:nvSpPr>
-          <p:cNvPr id="281" name="Rectangle 22"/>
+        </p:txBody>
+      </p:sp>
+      <p:sp>
+        <p:nvSpPr>
+          <p:cNvPr id="351" name="Rectangle 39"/>
           <p:cNvSpPr/>
           <p:nvPr/>
         </p:nvSpPr>
         <p:spPr>
           <a:xfrm>
-            <a:off x="8128000" y="2476500"/>
-            <a:ext cx="1651000" cy="1397000"/>
+            <a:off x="3200400" y="2794000"/>
+            <a:ext cx="1612900" cy="952500"/>
           </a:xfrm>
           <a:prstGeom prst="roundRect">
             <a:avLst/>
           </a:prstGeom>
           <a:solidFill>
-            <a:srgbClr val="F3E8FF"/>
+            <a:srgbClr val="EFF6FF"/>
           </a:solidFill>
-          <a:ln w="25400">
+          <a:ln w="19050">
             <a:solidFill>
-              <a:srgbClr val="9333EA"/>
+              <a:srgbClr val="60A5FA"/>
             </a:solidFill>
           </a:ln>
         </p:spPr>
@@ -3832,45 +4653,45 @@
           </a:fontRef>
         </p:style>
         <p:txBody>
-          <a:bodyPr/>
+          <a:bodyPr anchor="ctr"/>
           <a:lstStyle/>
           <a:p/>
         </p:txBody>
       </p:sp>
       <p:sp>
         <p:nvSpPr>
-          <p:cNvPr id="282" name="TextBox 23"/>
+          <p:cNvPr id="352" name="TextBox 40"/>
           <p:cNvSpPr txBox="1"/>
           <p:nvPr/>
         </p:nvSpPr>
         <p:spPr>
           <a:xfrm>
-            <a:off x="8255000" y="2641600"/>
-            <a:ext cx="1397000" cy="306571"/>
-          </a:xfrm>
-          <a:prstGeom prst="rect">
-            <a:avLst/>
-          </a:prstGeom>
-        </p:spPr>
-        <p:txBody>
-          <a:bodyPr wrap="square" anchor="ctr">
-            <a:spAutoFit/>
+            <a:off x="3340100" y="2895600"/>
+            <a:ext cx="1333500" cy="182880"/>
+          </a:xfrm>
+          <a:prstGeom prst="rect">
+            <a:avLst/>
+          </a:prstGeom>
+        </p:spPr>
+        <p:txBody>
+          <a:bodyPr wrap="square" lIns="0" tIns="0" rIns="0" bIns="0" anchor="ctr">
+            <a:normAutofit fontScale="100000"/>
           </a:bodyPr>
           <a:lstStyle/>
           <a:p>
             <a:pPr algn="ctr"/>
             <a:r>
-              <a:rPr sz="1400" b="1">
-                <a:solidFill>
-                  <a:srgbClr val="581C87"/>
+              <a:rPr sz="1200" b="1">
+                <a:solidFill>
+                  <a:srgbClr val="1D4ED8"/>
                 </a:solidFill>
                 <a:latin typeface="Inter"/>
               </a:rPr>
-              <a:t>GPU MMIO</a:t>
+              <a:t>DATA ROUTER</a:t>
             </a:r>
-            <a:endParaRPr sz="1400" b="1">
+            <a:endParaRPr sz="1200" b="1">
               <a:solidFill>
-                <a:srgbClr val="581C87"/>
+                <a:srgbClr val="1D4ED8"/>
               </a:solidFill>
               <a:latin typeface="Inter"/>
             </a:endParaRPr>
@@ -3879,38 +4700,38 @@
       </p:sp>
       <p:sp>
         <p:nvSpPr>
-          <p:cNvPr id="283" name="TextBox 24"/>
+          <p:cNvPr id="353" name="TextBox 41"/>
           <p:cNvSpPr txBox="1"/>
           <p:nvPr/>
         </p:nvSpPr>
         <p:spPr>
           <a:xfrm>
-            <a:off x="8255000" y="3009900"/>
-            <a:ext cx="1397000" cy="575485"/>
-          </a:xfrm>
-          <a:prstGeom prst="rect">
-            <a:avLst/>
-          </a:prstGeom>
-        </p:spPr>
-        <p:txBody>
-          <a:bodyPr wrap="square" anchor="ctr">
-            <a:spAutoFit/>
+            <a:off x="3340100" y="3175000"/>
+            <a:ext cx="1333500" cy="402336"/>
+          </a:xfrm>
+          <a:prstGeom prst="rect">
+            <a:avLst/>
+          </a:prstGeom>
+        </p:spPr>
+        <p:txBody>
+          <a:bodyPr wrap="square" lIns="0" tIns="0" rIns="0" bIns="0" anchor="ctr">
+            <a:normAutofit fontScale="100000"/>
           </a:bodyPr>
           <a:lstStyle/>
           <a:p>
             <a:pPr algn="ctr"/>
             <a:r>
-              <a:rPr sz="1050">
-                <a:solidFill>
-                  <a:srgbClr val="581C87"/>
+              <a:rPr sz="880" b="0">
+                <a:solidFill>
+                  <a:srgbClr val="475569"/>
                 </a:solidFill>
                 <a:latin typeface="Inter"/>
               </a:rPr>
-              <a:t>CTRL | STATUS</a:t>
+              <a:t>cached private RAM</a:t>
             </a:r>
-            <a:endParaRPr sz="1050">
+            <a:endParaRPr sz="880" b="0">
               <a:solidFill>
-                <a:srgbClr val="581C87"/>
+                <a:srgbClr val="475569"/>
               </a:solidFill>
               <a:latin typeface="Inter"/>
             </a:endParaRPr>
@@ -3918,61 +4739,43 @@
           <a:p>
             <a:pPr algn="ctr"/>
             <a:r>
-              <a:rPr sz="1050">
-                <a:solidFill>
-                  <a:srgbClr val="581C87"/>
+              <a:rPr sz="880" b="0">
+                <a:solidFill>
+                  <a:srgbClr val="475569"/>
                 </a:solidFill>
                 <a:latin typeface="Inter"/>
               </a:rPr>
-              <a:t>THREADS | SRC</a:t>
+              <a:t>uncached MMIO / buffers</a:t>
             </a:r>
-            <a:endParaRPr sz="1050">
+            <a:endParaRPr sz="880" b="0">
               <a:solidFill>
-                <a:srgbClr val="581C87"/>
+                <a:srgbClr val="475569"/>
               </a:solidFill>
               <a:latin typeface="Inter"/>
             </a:endParaRPr>
           </a:p>
-          <a:p>
-            <a:pPr algn="ctr"/>
-            <a:r>
-              <a:rPr sz="1050">
-                <a:solidFill>
-                  <a:srgbClr val="581C87"/>
-                </a:solidFill>
-                <a:latin typeface="Inter"/>
-              </a:rPr>
-              <a:t>DST | PROG_BASE</a:t>
-            </a:r>
-            <a:endParaRPr sz="1050">
-              <a:solidFill>
-                <a:srgbClr val="581C87"/>
-              </a:solidFill>
-              <a:latin typeface="Inter"/>
-            </a:endParaRPr>
-          </a:p>
-        </p:txBody>
-      </p:sp>
-      <p:sp>
-        <p:nvSpPr>
-          <p:cNvPr id="284" name="Rectangle 25"/>
+        </p:txBody>
+      </p:sp>
+      <p:sp>
+        <p:nvSpPr>
+          <p:cNvPr id="354" name="Rectangle 42"/>
           <p:cNvSpPr/>
           <p:nvPr/>
         </p:nvSpPr>
         <p:spPr>
           <a:xfrm>
-            <a:off x="10096500" y="2032000"/>
-            <a:ext cx="1905000" cy="2032000"/>
+            <a:off x="5143500" y="2794000"/>
+            <a:ext cx="1778000" cy="952500"/>
           </a:xfrm>
           <a:prstGeom prst="roundRect">
             <a:avLst/>
           </a:prstGeom>
           <a:solidFill>
-            <a:srgbClr val="DCFCE7"/>
+            <a:srgbClr val="EFF6FF"/>
           </a:solidFill>
-          <a:ln w="31750">
+          <a:ln w="19050">
             <a:solidFill>
-              <a:srgbClr val="16A34A"/>
+              <a:srgbClr val="60A5FA"/>
             </a:solidFill>
           </a:ln>
         </p:spPr>
@@ -3993,29 +4796,1481 @@
           </a:fontRef>
         </p:style>
         <p:txBody>
-          <a:bodyPr/>
+          <a:bodyPr anchor="ctr"/>
           <a:lstStyle/>
           <a:p/>
         </p:txBody>
       </p:sp>
       <p:sp>
         <p:nvSpPr>
-          <p:cNvPr id="285" name="TextBox 26"/>
+          <p:cNvPr id="355" name="TextBox 43"/>
           <p:cNvSpPr txBox="1"/>
           <p:nvPr/>
         </p:nvSpPr>
         <p:spPr>
           <a:xfrm>
-            <a:off x="10287000" y="2247900"/>
-            <a:ext cx="1524000" cy="352671"/>
-          </a:xfrm>
-          <a:prstGeom prst="rect">
-            <a:avLst/>
-          </a:prstGeom>
-        </p:spPr>
-        <p:txBody>
-          <a:bodyPr wrap="square" anchor="ctr">
-            <a:spAutoFit/>
+            <a:off x="5270500" y="2895600"/>
+            <a:ext cx="1524000" cy="182880"/>
+          </a:xfrm>
+          <a:prstGeom prst="rect">
+            <a:avLst/>
+          </a:prstGeom>
+        </p:spPr>
+        <p:txBody>
+          <a:bodyPr wrap="square" lIns="0" tIns="0" rIns="0" bIns="0" anchor="ctr">
+            <a:normAutofit fontScale="100000"/>
+          </a:bodyPr>
+          <a:lstStyle/>
+          <a:p>
+            <a:pPr algn="ctr"/>
+            <a:r>
+              <a:rPr sz="1200" b="1">
+                <a:solidFill>
+                  <a:srgbClr val="1D4ED8"/>
+                </a:solidFill>
+                <a:latin typeface="Inter"/>
+              </a:rPr>
+              <a:t>D-CACHE</a:t>
+            </a:r>
+            <a:endParaRPr sz="1200" b="1">
+              <a:solidFill>
+                <a:srgbClr val="1D4ED8"/>
+              </a:solidFill>
+              <a:latin typeface="Inter"/>
+            </a:endParaRPr>
+          </a:p>
+        </p:txBody>
+      </p:sp>
+      <p:sp>
+        <p:nvSpPr>
+          <p:cNvPr id="356" name="TextBox 44"/>
+          <p:cNvSpPr txBox="1"/>
+          <p:nvPr/>
+        </p:nvSpPr>
+        <p:spPr>
+          <a:xfrm>
+            <a:off x="5270500" y="3175000"/>
+            <a:ext cx="1524000" cy="268224"/>
+          </a:xfrm>
+          <a:prstGeom prst="rect">
+            <a:avLst/>
+          </a:prstGeom>
+        </p:spPr>
+        <p:txBody>
+          <a:bodyPr wrap="square" lIns="0" tIns="0" rIns="0" bIns="0" anchor="ctr">
+            <a:normAutofit fontScale="100000"/>
+          </a:bodyPr>
+          <a:lstStyle/>
+          <a:p>
+            <a:pPr algn="ctr"/>
+            <a:r>
+              <a:rPr sz="880" b="0">
+                <a:solidFill>
+                  <a:srgbClr val="475569"/>
+                </a:solidFill>
+                <a:latin typeface="Inter"/>
+              </a:rPr>
+              <a:t>write-back / allocate</a:t>
+            </a:r>
+            <a:endParaRPr sz="880" b="0">
+              <a:solidFill>
+                <a:srgbClr val="475569"/>
+              </a:solidFill>
+              <a:latin typeface="Inter"/>
+            </a:endParaRPr>
+          </a:p>
+          <a:p>
+            <a:pPr algn="ctr"/>
+            <a:r>
+              <a:rPr sz="880" b="0">
+                <a:solidFill>
+                  <a:srgbClr val="475569"/>
+                </a:solidFill>
+                <a:latin typeface="Inter"/>
+              </a:rPr>
+              <a:t>0x4000–0x4FFF only</a:t>
+            </a:r>
+            <a:endParaRPr sz="880" b="0">
+              <a:solidFill>
+                <a:srgbClr val="475569"/>
+              </a:solidFill>
+              <a:latin typeface="Inter"/>
+            </a:endParaRPr>
+          </a:p>
+        </p:txBody>
+      </p:sp>
+      <p:sp>
+        <p:nvSpPr>
+          <p:cNvPr id="357" name="Rectangle 45"/>
+          <p:cNvSpPr/>
+          <p:nvPr/>
+        </p:nvSpPr>
+        <p:spPr>
+          <a:xfrm>
+            <a:off x="3200400" y="4140200"/>
+            <a:ext cx="1612900" cy="1003300"/>
+          </a:xfrm>
+          <a:prstGeom prst="roundRect">
+            <a:avLst/>
+          </a:prstGeom>
+          <a:solidFill>
+            <a:srgbClr val="FEF3C7"/>
+          </a:solidFill>
+          <a:ln w="21590">
+            <a:solidFill>
+              <a:srgbClr val="D97706"/>
+            </a:solidFill>
+          </a:ln>
+        </p:spPr>
+        <p:style>
+          <a:lnRef idx="2">
+            <a:schemeClr val="accent1">
+              <a:shade val="50000"/>
+            </a:schemeClr>
+          </a:lnRef>
+          <a:fillRef idx="1">
+            <a:schemeClr val="accent1"/>
+          </a:fillRef>
+          <a:effectRef idx="0">
+            <a:schemeClr val="accent1"/>
+          </a:effectRef>
+          <a:fontRef idx="minor">
+            <a:schemeClr val="lt1"/>
+          </a:fontRef>
+        </p:style>
+        <p:txBody>
+          <a:bodyPr anchor="ctr"/>
+          <a:lstStyle/>
+          <a:p/>
+        </p:txBody>
+      </p:sp>
+      <p:sp>
+        <p:nvSpPr>
+          <p:cNvPr id="358" name="TextBox 46"/>
+          <p:cNvSpPr txBox="1"/>
+          <p:nvPr/>
+        </p:nvSpPr>
+        <p:spPr>
+          <a:xfrm>
+            <a:off x="3340100" y="4241800"/>
+            <a:ext cx="1333500" cy="167640"/>
+          </a:xfrm>
+          <a:prstGeom prst="rect">
+            <a:avLst/>
+          </a:prstGeom>
+        </p:spPr>
+        <p:txBody>
+          <a:bodyPr wrap="square" lIns="0" tIns="0" rIns="0" bIns="0" anchor="ctr">
+            <a:normAutofit fontScale="100000"/>
+          </a:bodyPr>
+          <a:lstStyle/>
+          <a:p>
+            <a:pPr algn="ctr"/>
+            <a:r>
+              <a:rPr sz="1100" b="1">
+                <a:solidFill>
+                  <a:srgbClr val="92400E"/>
+                </a:solidFill>
+                <a:latin typeface="Inter"/>
+              </a:rPr>
+              <a:t>CPU AXI ADAPTER</a:t>
+            </a:r>
+            <a:endParaRPr sz="1100" b="1">
+              <a:solidFill>
+                <a:srgbClr val="92400E"/>
+              </a:solidFill>
+              <a:latin typeface="Inter"/>
+            </a:endParaRPr>
+          </a:p>
+        </p:txBody>
+      </p:sp>
+      <p:sp>
+        <p:nvSpPr>
+          <p:cNvPr id="359" name="TextBox 47"/>
+          <p:cNvSpPr txBox="1"/>
+          <p:nvPr/>
+        </p:nvSpPr>
+        <p:spPr>
+          <a:xfrm>
+            <a:off x="3340100" y="4533900"/>
+            <a:ext cx="1333500" cy="402336"/>
+          </a:xfrm>
+          <a:prstGeom prst="rect">
+            <a:avLst/>
+          </a:prstGeom>
+        </p:spPr>
+        <p:txBody>
+          <a:bodyPr wrap="square" lIns="0" tIns="0" rIns="0" bIns="0" anchor="ctr">
+            <a:normAutofit fontScale="100000"/>
+          </a:bodyPr>
+          <a:lstStyle/>
+          <a:p>
+            <a:pPr algn="ctr"/>
+            <a:r>
+              <a:rPr sz="880" b="0">
+                <a:solidFill>
+                  <a:srgbClr val="78350F"/>
+                </a:solidFill>
+                <a:latin typeface="Inter"/>
+              </a:rPr>
+              <a:t>one outstanding</a:t>
+            </a:r>
+            <a:endParaRPr sz="880" b="0">
+              <a:solidFill>
+                <a:srgbClr val="78350F"/>
+              </a:solidFill>
+              <a:latin typeface="Inter"/>
+            </a:endParaRPr>
+          </a:p>
+          <a:p>
+            <a:pPr algn="ctr"/>
+            <a:r>
+              <a:rPr sz="880" b="0">
+                <a:solidFill>
+                  <a:srgbClr val="78350F"/>
+                </a:solidFill>
+                <a:latin typeface="Inter"/>
+              </a:rPr>
+              <a:t>byte strobes • sticky fault</a:t>
+            </a:r>
+            <a:endParaRPr sz="880" b="0">
+              <a:solidFill>
+                <a:srgbClr val="78350F"/>
+              </a:solidFill>
+              <a:latin typeface="Inter"/>
+            </a:endParaRPr>
+          </a:p>
+        </p:txBody>
+      </p:sp>
+      <p:sp>
+        <p:nvSpPr>
+          <p:cNvPr id="360" name="Rectangle 48"/>
+          <p:cNvSpPr/>
+          <p:nvPr/>
+        </p:nvSpPr>
+        <p:spPr>
+          <a:xfrm>
+            <a:off x="5143500" y="4140200"/>
+            <a:ext cx="1778000" cy="1003300"/>
+          </a:xfrm>
+          <a:prstGeom prst="roundRect">
+            <a:avLst/>
+          </a:prstGeom>
+          <a:solidFill>
+            <a:srgbClr val="FEF3C7"/>
+          </a:solidFill>
+          <a:ln w="21590">
+            <a:solidFill>
+              <a:srgbClr val="D97706"/>
+            </a:solidFill>
+          </a:ln>
+        </p:spPr>
+        <p:style>
+          <a:lnRef idx="2">
+            <a:schemeClr val="accent1">
+              <a:shade val="50000"/>
+            </a:schemeClr>
+          </a:lnRef>
+          <a:fillRef idx="1">
+            <a:schemeClr val="accent1"/>
+          </a:fillRef>
+          <a:effectRef idx="0">
+            <a:schemeClr val="accent1"/>
+          </a:effectRef>
+          <a:fontRef idx="minor">
+            <a:schemeClr val="lt1"/>
+          </a:fontRef>
+        </p:style>
+        <p:txBody>
+          <a:bodyPr anchor="ctr"/>
+          <a:lstStyle/>
+          <a:p/>
+        </p:txBody>
+      </p:sp>
+      <p:sp>
+        <p:nvSpPr>
+          <p:cNvPr id="361" name="TextBox 49"/>
+          <p:cNvSpPr txBox="1"/>
+          <p:nvPr/>
+        </p:nvSpPr>
+        <p:spPr>
+          <a:xfrm>
+            <a:off x="5270500" y="4241800"/>
+            <a:ext cx="1524000" cy="182880"/>
+          </a:xfrm>
+          <a:prstGeom prst="rect">
+            <a:avLst/>
+          </a:prstGeom>
+        </p:spPr>
+        <p:txBody>
+          <a:bodyPr wrap="square" lIns="0" tIns="0" rIns="0" bIns="0" anchor="ctr">
+            <a:normAutofit fontScale="100000"/>
+          </a:bodyPr>
+          <a:lstStyle/>
+          <a:p>
+            <a:pPr algn="ctr"/>
+            <a:r>
+              <a:rPr sz="1200" b="1">
+                <a:solidFill>
+                  <a:srgbClr val="92400E"/>
+                </a:solidFill>
+                <a:latin typeface="Inter"/>
+              </a:rPr>
+              <a:t>AXI4-LITE</a:t>
+            </a:r>
+            <a:endParaRPr sz="1200" b="1">
+              <a:solidFill>
+                <a:srgbClr val="92400E"/>
+              </a:solidFill>
+              <a:latin typeface="Inter"/>
+            </a:endParaRPr>
+          </a:p>
+        </p:txBody>
+      </p:sp>
+      <p:sp>
+        <p:nvSpPr>
+          <p:cNvPr id="362" name="TextBox 50"/>
+          <p:cNvSpPr txBox="1"/>
+          <p:nvPr/>
+        </p:nvSpPr>
+        <p:spPr>
+          <a:xfrm>
+            <a:off x="5270500" y="4533900"/>
+            <a:ext cx="1524000" cy="268224"/>
+          </a:xfrm>
+          <a:prstGeom prst="rect">
+            <a:avLst/>
+          </a:prstGeom>
+        </p:spPr>
+        <p:txBody>
+          <a:bodyPr wrap="square" lIns="0" tIns="0" rIns="0" bIns="0" anchor="ctr">
+            <a:normAutofit fontScale="100000"/>
+          </a:bodyPr>
+          <a:lstStyle/>
+          <a:p>
+            <a:pPr algn="ctr"/>
+            <a:r>
+              <a:rPr sz="880" b="0">
+                <a:solidFill>
+                  <a:srgbClr val="78350F"/>
+                </a:solidFill>
+                <a:latin typeface="Inter"/>
+              </a:rPr>
+              <a:t>address decode</a:t>
+            </a:r>
+            <a:endParaRPr sz="880" b="0">
+              <a:solidFill>
+                <a:srgbClr val="78350F"/>
+              </a:solidFill>
+              <a:latin typeface="Inter"/>
+            </a:endParaRPr>
+          </a:p>
+          <a:p>
+            <a:pPr algn="ctr"/>
+            <a:r>
+              <a:rPr sz="880" b="0">
+                <a:solidFill>
+                  <a:srgbClr val="78350F"/>
+                </a:solidFill>
+                <a:latin typeface="Inter"/>
+              </a:rPr>
+              <a:t>RAM + GPU MMIO</a:t>
+            </a:r>
+            <a:endParaRPr sz="880" b="0">
+              <a:solidFill>
+                <a:srgbClr val="78350F"/>
+              </a:solidFill>
+              <a:latin typeface="Inter"/>
+            </a:endParaRPr>
+          </a:p>
+        </p:txBody>
+      </p:sp>
+      <p:sp>
+        <p:nvSpPr>
+          <p:cNvPr id="363" name="Rectangle 51"/>
+          <p:cNvSpPr/>
+          <p:nvPr/>
+        </p:nvSpPr>
+        <p:spPr>
+          <a:xfrm>
+            <a:off x="3200400" y="5397500"/>
+            <a:ext cx="1612900" cy="787400"/>
+          </a:xfrm>
+          <a:prstGeom prst="roundRect">
+            <a:avLst/>
+          </a:prstGeom>
+          <a:solidFill>
+            <a:srgbClr val="F3E8FF"/>
+          </a:solidFill>
+          <a:ln w="20320">
+            <a:solidFill>
+              <a:srgbClr val="9333EA"/>
+            </a:solidFill>
+          </a:ln>
+        </p:spPr>
+        <p:style>
+          <a:lnRef idx="2">
+            <a:schemeClr val="accent1">
+              <a:shade val="50000"/>
+            </a:schemeClr>
+          </a:lnRef>
+          <a:fillRef idx="1">
+            <a:schemeClr val="accent1"/>
+          </a:fillRef>
+          <a:effectRef idx="0">
+            <a:schemeClr val="accent1"/>
+          </a:effectRef>
+          <a:fontRef idx="minor">
+            <a:schemeClr val="lt1"/>
+          </a:fontRef>
+        </p:style>
+        <p:txBody>
+          <a:bodyPr anchor="ctr"/>
+          <a:lstStyle/>
+          <a:p/>
+        </p:txBody>
+      </p:sp>
+      <p:sp>
+        <p:nvSpPr>
+          <p:cNvPr id="364" name="TextBox 52"/>
+          <p:cNvSpPr txBox="1"/>
+          <p:nvPr/>
+        </p:nvSpPr>
+        <p:spPr>
+          <a:xfrm>
+            <a:off x="3340100" y="5486400"/>
+            <a:ext cx="1333500" cy="167640"/>
+          </a:xfrm>
+          <a:prstGeom prst="rect">
+            <a:avLst/>
+          </a:prstGeom>
+        </p:spPr>
+        <p:txBody>
+          <a:bodyPr wrap="square" lIns="0" tIns="0" rIns="0" bIns="0" anchor="ctr">
+            <a:normAutofit fontScale="100000"/>
+          </a:bodyPr>
+          <a:lstStyle/>
+          <a:p>
+            <a:pPr algn="ctr"/>
+            <a:r>
+              <a:rPr sz="1100" b="1">
+                <a:solidFill>
+                  <a:srgbClr val="6B21A8"/>
+                </a:solidFill>
+                <a:latin typeface="Inter"/>
+              </a:rPr>
+              <a:t>GPU MMIO</a:t>
+            </a:r>
+            <a:endParaRPr sz="1100" b="1">
+              <a:solidFill>
+                <a:srgbClr val="6B21A8"/>
+              </a:solidFill>
+              <a:latin typeface="Inter"/>
+            </a:endParaRPr>
+          </a:p>
+        </p:txBody>
+      </p:sp>
+      <p:sp>
+        <p:nvSpPr>
+          <p:cNvPr id="365" name="TextBox 53"/>
+          <p:cNvSpPr txBox="1"/>
+          <p:nvPr/>
+        </p:nvSpPr>
+        <p:spPr>
+          <a:xfrm>
+            <a:off x="3340100" y="5753100"/>
+            <a:ext cx="1333500" cy="262128"/>
+          </a:xfrm>
+          <a:prstGeom prst="rect">
+            <a:avLst/>
+          </a:prstGeom>
+        </p:spPr>
+        <p:txBody>
+          <a:bodyPr wrap="square" lIns="0" tIns="0" rIns="0" bIns="0" anchor="ctr">
+            <a:normAutofit fontScale="100000"/>
+          </a:bodyPr>
+          <a:lstStyle/>
+          <a:p>
+            <a:pPr algn="ctr"/>
+            <a:r>
+              <a:rPr sz="860" b="0">
+                <a:solidFill>
+                  <a:srgbClr val="6B21A8"/>
+                </a:solidFill>
+                <a:latin typeface="Inter"/>
+              </a:rPr>
+              <a:t>shadow config</a:t>
+            </a:r>
+            <a:endParaRPr sz="860" b="0">
+              <a:solidFill>
+                <a:srgbClr val="6B21A8"/>
+              </a:solidFill>
+              <a:latin typeface="Inter"/>
+            </a:endParaRPr>
+          </a:p>
+          <a:p>
+            <a:pPr algn="ctr"/>
+            <a:r>
+              <a:rPr sz="860" b="0">
+                <a:solidFill>
+                  <a:srgbClr val="6B21A8"/>
+                </a:solidFill>
+                <a:latin typeface="Inter"/>
+              </a:rPr>
+              <a:t>busy + sticky done</a:t>
+            </a:r>
+            <a:endParaRPr sz="860" b="0">
+              <a:solidFill>
+                <a:srgbClr val="6B21A8"/>
+              </a:solidFill>
+              <a:latin typeface="Inter"/>
+            </a:endParaRPr>
+          </a:p>
+        </p:txBody>
+      </p:sp>
+      <p:sp>
+        <p:nvSpPr>
+          <p:cNvPr id="366" name="Rectangle 54"/>
+          <p:cNvSpPr/>
+          <p:nvPr/>
+        </p:nvSpPr>
+        <p:spPr>
+          <a:xfrm>
+            <a:off x="5143500" y="5397500"/>
+            <a:ext cx="1778000" cy="787400"/>
+          </a:xfrm>
+          <a:prstGeom prst="roundRect">
+            <a:avLst/>
+          </a:prstGeom>
+          <a:solidFill>
+            <a:srgbClr val="DCFCE7"/>
+          </a:solidFill>
+          <a:ln w="20320">
+            <a:solidFill>
+              <a:srgbClr val="16A34A"/>
+            </a:solidFill>
+          </a:ln>
+        </p:spPr>
+        <p:style>
+          <a:lnRef idx="2">
+            <a:schemeClr val="accent1">
+              <a:shade val="50000"/>
+            </a:schemeClr>
+          </a:lnRef>
+          <a:fillRef idx="1">
+            <a:schemeClr val="accent1"/>
+          </a:fillRef>
+          <a:effectRef idx="0">
+            <a:schemeClr val="accent1"/>
+          </a:effectRef>
+          <a:fontRef idx="minor">
+            <a:schemeClr val="lt1"/>
+          </a:fontRef>
+        </p:style>
+        <p:txBody>
+          <a:bodyPr anchor="ctr"/>
+          <a:lstStyle/>
+          <a:p/>
+        </p:txBody>
+      </p:sp>
+      <p:sp>
+        <p:nvSpPr>
+          <p:cNvPr id="367" name="TextBox 55"/>
+          <p:cNvSpPr txBox="1"/>
+          <p:nvPr/>
+        </p:nvSpPr>
+        <p:spPr>
+          <a:xfrm>
+            <a:off x="5270500" y="5486400"/>
+            <a:ext cx="1524000" cy="167640"/>
+          </a:xfrm>
+          <a:prstGeom prst="rect">
+            <a:avLst/>
+          </a:prstGeom>
+        </p:spPr>
+        <p:txBody>
+          <a:bodyPr wrap="square" lIns="0" tIns="0" rIns="0" bIns="0" anchor="ctr">
+            <a:normAutofit fontScale="100000"/>
+          </a:bodyPr>
+          <a:lstStyle/>
+          <a:p>
+            <a:pPr algn="ctr"/>
+            <a:r>
+              <a:rPr sz="1100" b="1">
+                <a:solidFill>
+                  <a:srgbClr val="166534"/>
+                </a:solidFill>
+                <a:latin typeface="Inter"/>
+              </a:rPr>
+              <a:t>SHARED RAM</a:t>
+            </a:r>
+            <a:endParaRPr sz="1100" b="1">
+              <a:solidFill>
+                <a:srgbClr val="166534"/>
+              </a:solidFill>
+              <a:latin typeface="Inter"/>
+            </a:endParaRPr>
+          </a:p>
+        </p:txBody>
+      </p:sp>
+      <p:sp>
+        <p:nvSpPr>
+          <p:cNvPr id="368" name="TextBox 56"/>
+          <p:cNvSpPr txBox="1"/>
+          <p:nvPr/>
+        </p:nvSpPr>
+        <p:spPr>
+          <a:xfrm>
+            <a:off x="5270500" y="5753100"/>
+            <a:ext cx="1524000" cy="262128"/>
+          </a:xfrm>
+          <a:prstGeom prst="rect">
+            <a:avLst/>
+          </a:prstGeom>
+        </p:spPr>
+        <p:txBody>
+          <a:bodyPr wrap="square" lIns="0" tIns="0" rIns="0" bIns="0" anchor="ctr">
+            <a:normAutofit fontScale="100000"/>
+          </a:bodyPr>
+          <a:lstStyle/>
+          <a:p>
+            <a:pPr algn="ctr"/>
+            <a:r>
+              <a:rPr sz="860" b="0">
+                <a:solidFill>
+                  <a:srgbClr val="166534"/>
+                </a:solidFill>
+                <a:latin typeface="Inter"/>
+              </a:rPr>
+              <a:t>uncached framebuffers</a:t>
+            </a:r>
+            <a:endParaRPr sz="860" b="0">
+              <a:solidFill>
+                <a:srgbClr val="166534"/>
+              </a:solidFill>
+              <a:latin typeface="Inter"/>
+            </a:endParaRPr>
+          </a:p>
+          <a:p>
+            <a:pPr algn="ctr"/>
+            <a:r>
+              <a:rPr sz="860" b="0">
+                <a:solidFill>
+                  <a:srgbClr val="166534"/>
+                </a:solidFill>
+                <a:latin typeface="Inter"/>
+              </a:rPr>
+              <a:t>CPU-owned dual ports</a:t>
+            </a:r>
+            <a:endParaRPr sz="860" b="0">
+              <a:solidFill>
+                <a:srgbClr val="166534"/>
+              </a:solidFill>
+              <a:latin typeface="Inter"/>
+            </a:endParaRPr>
+          </a:p>
+        </p:txBody>
+      </p:sp>
+      <p:sp>
+        <p:nvSpPr>
+          <p:cNvPr id="369" name="Rectangle 57"/>
+          <p:cNvSpPr/>
+          <p:nvPr/>
+        </p:nvSpPr>
+        <p:spPr>
+          <a:xfrm>
+            <a:off x="7594600" y="1676400"/>
+            <a:ext cx="889000" cy="762000"/>
+          </a:xfrm>
+          <a:prstGeom prst="roundRect">
+            <a:avLst/>
+          </a:prstGeom>
+          <a:solidFill>
+            <a:srgbClr val="F3E8FF"/>
+          </a:solidFill>
+          <a:ln w="19050">
+            <a:solidFill>
+              <a:srgbClr val="A855F7"/>
+            </a:solidFill>
+          </a:ln>
+        </p:spPr>
+        <p:style>
+          <a:lnRef idx="2">
+            <a:schemeClr val="accent1">
+              <a:shade val="50000"/>
+            </a:schemeClr>
+          </a:lnRef>
+          <a:fillRef idx="1">
+            <a:schemeClr val="accent1"/>
+          </a:fillRef>
+          <a:effectRef idx="0">
+            <a:schemeClr val="accent1"/>
+          </a:effectRef>
+          <a:fontRef idx="minor">
+            <a:schemeClr val="lt1"/>
+          </a:fontRef>
+        </p:style>
+        <p:txBody>
+          <a:bodyPr anchor="ctr"/>
+          <a:lstStyle/>
+          <a:p/>
+        </p:txBody>
+      </p:sp>
+      <p:sp>
+        <p:nvSpPr>
+          <p:cNvPr id="370" name="TextBox 58"/>
+          <p:cNvSpPr txBox="1"/>
+          <p:nvPr/>
+        </p:nvSpPr>
+        <p:spPr>
+          <a:xfrm>
+            <a:off x="7658100" y="1752600"/>
+            <a:ext cx="762000" cy="144780"/>
+          </a:xfrm>
+          <a:prstGeom prst="rect">
+            <a:avLst/>
+          </a:prstGeom>
+        </p:spPr>
+        <p:txBody>
+          <a:bodyPr wrap="square" lIns="0" tIns="0" rIns="0" bIns="0" anchor="ctr">
+            <a:normAutofit fontScale="100000"/>
+          </a:bodyPr>
+          <a:lstStyle/>
+          <a:p>
+            <a:pPr algn="ctr"/>
+            <a:r>
+              <a:rPr sz="950" b="1">
+                <a:solidFill>
+                  <a:srgbClr val="6B21A8"/>
+                </a:solidFill>
+                <a:latin typeface="Inter"/>
+              </a:rPr>
+              <a:t>COMMAND</a:t>
+            </a:r>
+            <a:endParaRPr sz="950" b="1">
+              <a:solidFill>
+                <a:srgbClr val="6B21A8"/>
+              </a:solidFill>
+              <a:latin typeface="Inter"/>
+            </a:endParaRPr>
+          </a:p>
+        </p:txBody>
+      </p:sp>
+      <p:sp>
+        <p:nvSpPr>
+          <p:cNvPr id="371" name="TextBox 59"/>
+          <p:cNvSpPr txBox="1"/>
+          <p:nvPr/>
+        </p:nvSpPr>
+        <p:spPr>
+          <a:xfrm>
+            <a:off x="7658100" y="2006600"/>
+            <a:ext cx="762000" cy="240792"/>
+          </a:xfrm>
+          <a:prstGeom prst="rect">
+            <a:avLst/>
+          </a:prstGeom>
+        </p:spPr>
+        <p:txBody>
+          <a:bodyPr wrap="square" lIns="0" tIns="0" rIns="0" bIns="0" anchor="ctr">
+            <a:normAutofit fontScale="100000"/>
+          </a:bodyPr>
+          <a:lstStyle/>
+          <a:p>
+            <a:pPr algn="ctr"/>
+            <a:r>
+              <a:rPr sz="790" b="0">
+                <a:solidFill>
+                  <a:srgbClr val="7E22CE"/>
+                </a:solidFill>
+                <a:latin typeface="Inter"/>
+              </a:rPr>
+              <a:t>atomic launch</a:t>
+            </a:r>
+            <a:endParaRPr sz="790" b="0">
+              <a:solidFill>
+                <a:srgbClr val="7E22CE"/>
+              </a:solidFill>
+              <a:latin typeface="Inter"/>
+            </a:endParaRPr>
+          </a:p>
+          <a:p>
+            <a:pPr algn="ctr"/>
+            <a:r>
+              <a:rPr sz="790" b="0">
+                <a:solidFill>
+                  <a:srgbClr val="7E22CE"/>
+                </a:solidFill>
+                <a:latin typeface="Inter"/>
+              </a:rPr>
+              <a:t>config →</a:t>
+            </a:r>
+            <a:endParaRPr sz="790" b="0">
+              <a:solidFill>
+                <a:srgbClr val="7E22CE"/>
+              </a:solidFill>
+              <a:latin typeface="Inter"/>
+            </a:endParaRPr>
+          </a:p>
+        </p:txBody>
+      </p:sp>
+      <p:sp>
+        <p:nvSpPr>
+          <p:cNvPr id="372" name="Rectangle 60"/>
+          <p:cNvSpPr/>
+          <p:nvPr/>
+        </p:nvSpPr>
+        <p:spPr>
+          <a:xfrm>
+            <a:off x="7594600" y="2514600"/>
+            <a:ext cx="889000" cy="533400"/>
+          </a:xfrm>
+          <a:prstGeom prst="roundRect">
+            <a:avLst/>
+          </a:prstGeom>
+          <a:solidFill>
+            <a:srgbClr val="F3E8FF"/>
+          </a:solidFill>
+          <a:ln w="19050">
+            <a:solidFill>
+              <a:srgbClr val="A855F7"/>
+            </a:solidFill>
+          </a:ln>
+        </p:spPr>
+        <p:style>
+          <a:lnRef idx="2">
+            <a:schemeClr val="accent1">
+              <a:shade val="50000"/>
+            </a:schemeClr>
+          </a:lnRef>
+          <a:fillRef idx="1">
+            <a:schemeClr val="accent1"/>
+          </a:fillRef>
+          <a:effectRef idx="0">
+            <a:schemeClr val="accent1"/>
+          </a:effectRef>
+          <a:fontRef idx="minor">
+            <a:schemeClr val="lt1"/>
+          </a:fontRef>
+        </p:style>
+        <p:txBody>
+          <a:bodyPr anchor="ctr"/>
+          <a:lstStyle/>
+          <a:p/>
+        </p:txBody>
+      </p:sp>
+      <p:sp>
+        <p:nvSpPr>
+          <p:cNvPr id="373" name="TextBox 61"/>
+          <p:cNvSpPr txBox="1"/>
+          <p:nvPr/>
+        </p:nvSpPr>
+        <p:spPr>
+          <a:xfrm>
+            <a:off x="7658100" y="2578100"/>
+            <a:ext cx="762000" cy="129540"/>
+          </a:xfrm>
+          <a:prstGeom prst="rect">
+            <a:avLst/>
+          </a:prstGeom>
+        </p:spPr>
+        <p:txBody>
+          <a:bodyPr wrap="square" lIns="0" tIns="0" rIns="0" bIns="0" anchor="ctr">
+            <a:normAutofit fontScale="100000"/>
+          </a:bodyPr>
+          <a:lstStyle/>
+          <a:p>
+            <a:pPr algn="ctr"/>
+            <a:r>
+              <a:rPr sz="850" b="1">
+                <a:solidFill>
+                  <a:srgbClr val="6B21A8"/>
+                </a:solidFill>
+                <a:latin typeface="Inter"/>
+              </a:rPr>
+              <a:t>COMPLETE</a:t>
+            </a:r>
+            <a:endParaRPr sz="850" b="1">
+              <a:solidFill>
+                <a:srgbClr val="6B21A8"/>
+              </a:solidFill>
+              <a:latin typeface="Inter"/>
+            </a:endParaRPr>
+          </a:p>
+        </p:txBody>
+      </p:sp>
+      <p:sp>
+        <p:nvSpPr>
+          <p:cNvPr id="374" name="TextBox 62"/>
+          <p:cNvSpPr txBox="1"/>
+          <p:nvPr/>
+        </p:nvSpPr>
+        <p:spPr>
+          <a:xfrm>
+            <a:off x="7658100" y="2768600"/>
+            <a:ext cx="762000" cy="120396"/>
+          </a:xfrm>
+          <a:prstGeom prst="rect">
+            <a:avLst/>
+          </a:prstGeom>
+        </p:spPr>
+        <p:txBody>
+          <a:bodyPr wrap="square" lIns="0" tIns="0" rIns="0" bIns="0" anchor="ctr">
+            <a:normAutofit fontScale="100000"/>
+          </a:bodyPr>
+          <a:lstStyle/>
+          <a:p>
+            <a:pPr algn="ctr"/>
+            <a:r>
+              <a:rPr sz="790" b="0">
+                <a:solidFill>
+                  <a:srgbClr val="7E22CE"/>
+                </a:solidFill>
+                <a:latin typeface="Inter"/>
+              </a:rPr>
+              <a:t>event ←</a:t>
+            </a:r>
+            <a:endParaRPr sz="790" b="0">
+              <a:solidFill>
+                <a:srgbClr val="7E22CE"/>
+              </a:solidFill>
+              <a:latin typeface="Inter"/>
+            </a:endParaRPr>
+          </a:p>
+        </p:txBody>
+      </p:sp>
+      <p:sp>
+        <p:nvSpPr>
+          <p:cNvPr id="375" name="Rectangle 63"/>
+          <p:cNvSpPr/>
+          <p:nvPr/>
+        </p:nvSpPr>
+        <p:spPr>
+          <a:xfrm>
+            <a:off x="7594600" y="3149600"/>
+            <a:ext cx="889000" cy="939800"/>
+          </a:xfrm>
+          <a:prstGeom prst="roundRect">
+            <a:avLst/>
+          </a:prstGeom>
+          <a:solidFill>
+            <a:srgbClr val="DCFCE7"/>
+          </a:solidFill>
+          <a:ln w="19050">
+            <a:solidFill>
+              <a:srgbClr val="22C55E"/>
+            </a:solidFill>
+          </a:ln>
+        </p:spPr>
+        <p:style>
+          <a:lnRef idx="2">
+            <a:schemeClr val="accent1">
+              <a:shade val="50000"/>
+            </a:schemeClr>
+          </a:lnRef>
+          <a:fillRef idx="1">
+            <a:schemeClr val="accent1"/>
+          </a:fillRef>
+          <a:effectRef idx="0">
+            <a:schemeClr val="accent1"/>
+          </a:effectRef>
+          <a:fontRef idx="minor">
+            <a:schemeClr val="lt1"/>
+          </a:fontRef>
+        </p:style>
+        <p:txBody>
+          <a:bodyPr anchor="ctr"/>
+          <a:lstStyle/>
+          <a:p/>
+        </p:txBody>
+      </p:sp>
+      <p:sp>
+        <p:nvSpPr>
+          <p:cNvPr id="376" name="TextBox 64"/>
+          <p:cNvSpPr txBox="1"/>
+          <p:nvPr/>
+        </p:nvSpPr>
+        <p:spPr>
+          <a:xfrm>
+            <a:off x="7658100" y="3238500"/>
+            <a:ext cx="762000" cy="144780"/>
+          </a:xfrm>
+          <a:prstGeom prst="rect">
+            <a:avLst/>
+          </a:prstGeom>
+        </p:spPr>
+        <p:txBody>
+          <a:bodyPr wrap="square" lIns="0" tIns="0" rIns="0" bIns="0" anchor="ctr">
+            <a:normAutofit fontScale="100000"/>
+          </a:bodyPr>
+          <a:lstStyle/>
+          <a:p>
+            <a:pPr algn="ctr"/>
+            <a:r>
+              <a:rPr sz="950" b="1">
+                <a:solidFill>
+                  <a:srgbClr val="166534"/>
+                </a:solidFill>
+                <a:latin typeface="Inter"/>
+              </a:rPr>
+              <a:t>MEMORY</a:t>
+            </a:r>
+            <a:endParaRPr sz="950" b="1">
+              <a:solidFill>
+                <a:srgbClr val="166534"/>
+              </a:solidFill>
+              <a:latin typeface="Inter"/>
+            </a:endParaRPr>
+          </a:p>
+        </p:txBody>
+      </p:sp>
+      <p:sp>
+        <p:nvSpPr>
+          <p:cNvPr id="377" name="TextBox 65"/>
+          <p:cNvSpPr txBox="1"/>
+          <p:nvPr/>
+        </p:nvSpPr>
+        <p:spPr>
+          <a:xfrm>
+            <a:off x="7658100" y="3492500"/>
+            <a:ext cx="762000" cy="361188"/>
+          </a:xfrm>
+          <a:prstGeom prst="rect">
+            <a:avLst/>
+          </a:prstGeom>
+        </p:spPr>
+        <p:txBody>
+          <a:bodyPr wrap="square" lIns="0" tIns="0" rIns="0" bIns="0" anchor="ctr">
+            <a:normAutofit fontScale="100000"/>
+          </a:bodyPr>
+          <a:lstStyle/>
+          <a:p>
+            <a:pPr algn="ctr"/>
+            <a:r>
+              <a:rPr sz="790" b="0">
+                <a:solidFill>
+                  <a:srgbClr val="15803D"/>
+                </a:solidFill>
+                <a:latin typeface="Inter"/>
+              </a:rPr>
+              <a:t>request →</a:t>
+            </a:r>
+            <a:endParaRPr sz="790" b="0">
+              <a:solidFill>
+                <a:srgbClr val="15803D"/>
+              </a:solidFill>
+              <a:latin typeface="Inter"/>
+            </a:endParaRPr>
+          </a:p>
+          <a:p>
+            <a:pPr algn="ctr"/>
+            <a:r>
+              <a:rPr sz="790" b="0">
+                <a:solidFill>
+                  <a:srgbClr val="15803D"/>
+                </a:solidFill>
+                <a:latin typeface="Inter"/>
+              </a:rPr>
+              <a:t>response ←</a:t>
+            </a:r>
+            <a:endParaRPr sz="790" b="0">
+              <a:solidFill>
+                <a:srgbClr val="15803D"/>
+              </a:solidFill>
+              <a:latin typeface="Inter"/>
+            </a:endParaRPr>
+          </a:p>
+          <a:p>
+            <a:pPr algn="ctr"/>
+            <a:r>
+              <a:rPr sz="790" b="0">
+                <a:solidFill>
+                  <a:srgbClr val="15803D"/>
+                </a:solidFill>
+                <a:latin typeface="Inter"/>
+              </a:rPr>
+              <a:t>write ack</a:t>
+            </a:r>
+            <a:endParaRPr sz="790" b="0">
+              <a:solidFill>
+                <a:srgbClr val="15803D"/>
+              </a:solidFill>
+              <a:latin typeface="Inter"/>
+            </a:endParaRPr>
+          </a:p>
+        </p:txBody>
+      </p:sp>
+      <p:sp>
+        <p:nvSpPr>
+          <p:cNvPr id="378" name="Rectangle 66"/>
+          <p:cNvSpPr/>
+          <p:nvPr/>
+        </p:nvSpPr>
+        <p:spPr>
+          <a:xfrm>
+            <a:off x="7594600" y="4267200"/>
+            <a:ext cx="889000" cy="660400"/>
+          </a:xfrm>
+          <a:prstGeom prst="roundRect">
+            <a:avLst/>
+          </a:prstGeom>
+          <a:solidFill>
+            <a:srgbClr val="F3E8FF"/>
+          </a:solidFill>
+          <a:ln w="19050">
+            <a:solidFill>
+              <a:srgbClr val="A855F7"/>
+            </a:solidFill>
+          </a:ln>
+        </p:spPr>
+        <p:style>
+          <a:lnRef idx="2">
+            <a:schemeClr val="accent1">
+              <a:shade val="50000"/>
+            </a:schemeClr>
+          </a:lnRef>
+          <a:fillRef idx="1">
+            <a:schemeClr val="accent1"/>
+          </a:fillRef>
+          <a:effectRef idx="0">
+            <a:schemeClr val="accent1"/>
+          </a:effectRef>
+          <a:fontRef idx="minor">
+            <a:schemeClr val="lt1"/>
+          </a:fontRef>
+        </p:style>
+        <p:txBody>
+          <a:bodyPr anchor="ctr"/>
+          <a:lstStyle/>
+          <a:p/>
+        </p:txBody>
+      </p:sp>
+      <p:sp>
+        <p:nvSpPr>
+          <p:cNvPr id="379" name="TextBox 67"/>
+          <p:cNvSpPr txBox="1"/>
+          <p:nvPr/>
+        </p:nvSpPr>
+        <p:spPr>
+          <a:xfrm>
+            <a:off x="7658100" y="4343400"/>
+            <a:ext cx="762000" cy="137160"/>
+          </a:xfrm>
+          <a:prstGeom prst="rect">
+            <a:avLst/>
+          </a:prstGeom>
+        </p:spPr>
+        <p:txBody>
+          <a:bodyPr wrap="square" lIns="0" tIns="0" rIns="0" bIns="0" anchor="ctr">
+            <a:normAutofit fontScale="100000"/>
+          </a:bodyPr>
+          <a:lstStyle/>
+          <a:p>
+            <a:pPr algn="ctr"/>
+            <a:r>
+              <a:rPr sz="900" b="1">
+                <a:solidFill>
+                  <a:srgbClr val="6B21A8"/>
+                </a:solidFill>
+                <a:latin typeface="Inter"/>
+              </a:rPr>
+              <a:t>RESET</a:t>
+            </a:r>
+            <a:endParaRPr sz="900" b="1">
+              <a:solidFill>
+                <a:srgbClr val="6B21A8"/>
+              </a:solidFill>
+              <a:latin typeface="Inter"/>
+            </a:endParaRPr>
+          </a:p>
+        </p:txBody>
+      </p:sp>
+      <p:sp>
+        <p:nvSpPr>
+          <p:cNvPr id="380" name="TextBox 68"/>
+          <p:cNvSpPr txBox="1"/>
+          <p:nvPr/>
+        </p:nvSpPr>
+        <p:spPr>
+          <a:xfrm>
+            <a:off x="7658100" y="4546600"/>
+            <a:ext cx="762000" cy="231648"/>
+          </a:xfrm>
+          <a:prstGeom prst="rect">
+            <a:avLst/>
+          </a:prstGeom>
+        </p:spPr>
+        <p:txBody>
+          <a:bodyPr wrap="square" lIns="0" tIns="0" rIns="0" bIns="0" anchor="ctr">
+            <a:normAutofit fontScale="100000"/>
+          </a:bodyPr>
+          <a:lstStyle/>
+          <a:p>
+            <a:pPr algn="ctr"/>
+            <a:r>
+              <a:rPr sz="760" b="0">
+                <a:solidFill>
+                  <a:srgbClr val="7E22CE"/>
+                </a:solidFill>
+                <a:latin typeface="Inter"/>
+              </a:rPr>
+              <a:t>async assert</a:t>
+            </a:r>
+            <a:endParaRPr sz="760" b="0">
+              <a:solidFill>
+                <a:srgbClr val="7E22CE"/>
+              </a:solidFill>
+              <a:latin typeface="Inter"/>
+            </a:endParaRPr>
+          </a:p>
+          <a:p>
+            <a:pPr algn="ctr"/>
+            <a:r>
+              <a:rPr sz="760" b="0">
+                <a:solidFill>
+                  <a:srgbClr val="7E22CE"/>
+                </a:solidFill>
+                <a:latin typeface="Inter"/>
+              </a:rPr>
+              <a:t>sync release</a:t>
+            </a:r>
+            <a:endParaRPr sz="760" b="0">
+              <a:solidFill>
+                <a:srgbClr val="7E22CE"/>
+              </a:solidFill>
+              <a:latin typeface="Inter"/>
+            </a:endParaRPr>
+          </a:p>
+        </p:txBody>
+      </p:sp>
+      <p:sp>
+        <p:nvSpPr>
+          <p:cNvPr id="381" name="Rectangle 69"/>
+          <p:cNvSpPr/>
+          <p:nvPr/>
+        </p:nvSpPr>
+        <p:spPr>
+          <a:xfrm>
+            <a:off x="7594600" y="5334000"/>
+            <a:ext cx="889000" cy="635000"/>
+          </a:xfrm>
+          <a:prstGeom prst="roundRect">
+            <a:avLst/>
+          </a:prstGeom>
+          <a:solidFill>
+            <a:srgbClr val="F1F5F9"/>
+          </a:solidFill>
+          <a:ln w="19050">
+            <a:solidFill>
+              <a:srgbClr val="94A3B8"/>
+            </a:solidFill>
+          </a:ln>
+        </p:spPr>
+        <p:style>
+          <a:lnRef idx="2">
+            <a:schemeClr val="accent1">
+              <a:shade val="50000"/>
+            </a:schemeClr>
+          </a:lnRef>
+          <a:fillRef idx="1">
+            <a:schemeClr val="accent1"/>
+          </a:fillRef>
+          <a:effectRef idx="0">
+            <a:schemeClr val="accent1"/>
+          </a:effectRef>
+          <a:fontRef idx="minor">
+            <a:schemeClr val="lt1"/>
+          </a:fontRef>
+        </p:style>
+        <p:txBody>
+          <a:bodyPr anchor="ctr"/>
+          <a:lstStyle/>
+          <a:p/>
+        </p:txBody>
+      </p:sp>
+      <p:sp>
+        <p:nvSpPr>
+          <p:cNvPr id="382" name="TextBox 70"/>
+          <p:cNvSpPr txBox="1"/>
+          <p:nvPr/>
+        </p:nvSpPr>
+        <p:spPr>
+          <a:xfrm>
+            <a:off x="7658100" y="5410200"/>
+            <a:ext cx="762000" cy="132588"/>
+          </a:xfrm>
+          <a:prstGeom prst="rect">
+            <a:avLst/>
+          </a:prstGeom>
+        </p:spPr>
+        <p:txBody>
+          <a:bodyPr wrap="square" lIns="0" tIns="0" rIns="0" bIns="0" anchor="ctr">
+            <a:normAutofit fontScale="100000"/>
+          </a:bodyPr>
+          <a:lstStyle/>
+          <a:p>
+            <a:pPr algn="ctr"/>
+            <a:r>
+              <a:rPr sz="870" b="1">
+                <a:solidFill>
+                  <a:srgbClr val="334155"/>
+                </a:solidFill>
+                <a:latin typeface="Inter"/>
+              </a:rPr>
+              <a:t>PROGRAM</a:t>
+            </a:r>
+            <a:endParaRPr sz="870" b="1">
+              <a:solidFill>
+                <a:srgbClr val="334155"/>
+              </a:solidFill>
+              <a:latin typeface="Inter"/>
+            </a:endParaRPr>
+          </a:p>
+        </p:txBody>
+      </p:sp>
+      <p:sp>
+        <p:nvSpPr>
+          <p:cNvPr id="383" name="TextBox 71"/>
+          <p:cNvSpPr txBox="1"/>
+          <p:nvPr/>
+        </p:nvSpPr>
+        <p:spPr>
+          <a:xfrm>
+            <a:off x="7658100" y="5651500"/>
+            <a:ext cx="762000" cy="117348"/>
+          </a:xfrm>
+          <a:prstGeom prst="rect">
+            <a:avLst/>
+          </a:prstGeom>
+        </p:spPr>
+        <p:txBody>
+          <a:bodyPr wrap="square" lIns="0" tIns="0" rIns="0" bIns="0" anchor="ctr">
+            <a:normAutofit fontScale="100000"/>
+          </a:bodyPr>
+          <a:lstStyle/>
+          <a:p>
+            <a:pPr algn="ctr"/>
+            <a:r>
+              <a:rPr sz="770" b="0">
+                <a:solidFill>
+                  <a:srgbClr val="475569"/>
+                </a:solidFill>
+                <a:latin typeface="Inter"/>
+              </a:rPr>
+              <a:t>boot write →</a:t>
+            </a:r>
+            <a:endParaRPr sz="770" b="0">
+              <a:solidFill>
+                <a:srgbClr val="475569"/>
+              </a:solidFill>
+              <a:latin typeface="Inter"/>
+            </a:endParaRPr>
+          </a:p>
+        </p:txBody>
+      </p:sp>
+      <p:sp>
+        <p:nvSpPr>
+          <p:cNvPr id="384" name="TextBox 72"/>
+          <p:cNvSpPr txBox="1"/>
+          <p:nvPr/>
+        </p:nvSpPr>
+        <p:spPr>
+          <a:xfrm>
+            <a:off x="7594600" y="6019800"/>
+            <a:ext cx="889000" cy="210312"/>
+          </a:xfrm>
+          <a:prstGeom prst="rect">
+            <a:avLst/>
+          </a:prstGeom>
+        </p:spPr>
+        <p:txBody>
+          <a:bodyPr wrap="square" lIns="0" tIns="0" rIns="0" bIns="0" anchor="ctr">
+            <a:normAutofit fontScale="100000"/>
+          </a:bodyPr>
+          <a:lstStyle/>
+          <a:p>
+            <a:pPr algn="ctr"/>
+            <a:r>
+              <a:rPr sz="690" b="0">
+                <a:solidFill>
+                  <a:srgbClr val="64748B"/>
+                </a:solidFill>
+                <a:latin typeface="Inter"/>
+              </a:rPr>
+              <a:t>Gray pointers • 2-FF sync</a:t>
+            </a:r>
+            <a:endParaRPr sz="690" b="0">
+              <a:solidFill>
+                <a:srgbClr val="64748B"/>
+              </a:solidFill>
+              <a:latin typeface="Inter"/>
+            </a:endParaRPr>
+          </a:p>
+        </p:txBody>
+      </p:sp>
+      <p:sp>
+        <p:nvSpPr>
+          <p:cNvPr id="385" name="Rectangle 73"/>
+          <p:cNvSpPr/>
+          <p:nvPr/>
+        </p:nvSpPr>
+        <p:spPr>
+          <a:xfrm>
+            <a:off x="9042400" y="1600200"/>
+            <a:ext cx="2286000" cy="2387600"/>
+          </a:xfrm>
+          <a:prstGeom prst="roundRect">
+            <a:avLst/>
+          </a:prstGeom>
+          <a:solidFill>
+            <a:srgbClr val="DCFCE7"/>
+          </a:solidFill>
+          <a:ln w="26670">
+            <a:solidFill>
+              <a:srgbClr val="16A34A"/>
+            </a:solidFill>
+          </a:ln>
+        </p:spPr>
+        <p:style>
+          <a:lnRef idx="2">
+            <a:schemeClr val="accent1">
+              <a:shade val="50000"/>
+            </a:schemeClr>
+          </a:lnRef>
+          <a:fillRef idx="1">
+            <a:schemeClr val="accent1"/>
+          </a:fillRef>
+          <a:effectRef idx="0">
+            <a:schemeClr val="accent1"/>
+          </a:effectRef>
+          <a:fontRef idx="minor">
+            <a:schemeClr val="lt1"/>
+          </a:fontRef>
+        </p:style>
+        <p:txBody>
+          <a:bodyPr anchor="ctr"/>
+          <a:lstStyle/>
+          <a:p/>
+        </p:txBody>
+      </p:sp>
+      <p:sp>
+        <p:nvSpPr>
+          <p:cNvPr id="386" name="TextBox 74"/>
+          <p:cNvSpPr txBox="1"/>
+          <p:nvPr/>
+        </p:nvSpPr>
+        <p:spPr>
+          <a:xfrm>
+            <a:off x="9232900" y="1778000"/>
+            <a:ext cx="1905000" cy="259080"/>
+          </a:xfrm>
+          <a:prstGeom prst="rect">
+            <a:avLst/>
+          </a:prstGeom>
+        </p:spPr>
+        <p:txBody>
+          <a:bodyPr wrap="square" lIns="0" tIns="0" rIns="0" bIns="0" anchor="ctr">
+            <a:normAutofit fontScale="100000"/>
           </a:bodyPr>
           <a:lstStyle/>
           <a:p>
@@ -4040,38 +6295,38 @@
       </p:sp>
       <p:sp>
         <p:nvSpPr>
-          <p:cNvPr id="286" name="TextBox 27"/>
+          <p:cNvPr id="387" name="TextBox 75"/>
           <p:cNvSpPr txBox="1"/>
           <p:nvPr/>
         </p:nvSpPr>
         <p:spPr>
           <a:xfrm>
-            <a:off x="10223500" y="2667000"/>
-            <a:ext cx="1651000" cy="767566"/>
-          </a:xfrm>
-          <a:prstGeom prst="rect">
-            <a:avLst/>
-          </a:prstGeom>
-        </p:spPr>
-        <p:txBody>
-          <a:bodyPr wrap="square" anchor="ctr">
-            <a:spAutoFit/>
+            <a:off x="9232900" y="2209800"/>
+            <a:ext cx="1905000" cy="670560"/>
+          </a:xfrm>
+          <a:prstGeom prst="rect">
+            <a:avLst/>
+          </a:prstGeom>
+        </p:spPr>
+        <p:txBody>
+          <a:bodyPr wrap="square" lIns="0" tIns="0" rIns="0" bIns="0" anchor="ctr">
+            <a:normAutofit fontScale="100000"/>
           </a:bodyPr>
           <a:lstStyle/>
           <a:p>
             <a:pPr algn="ctr"/>
             <a:r>
-              <a:rPr sz="1100">
-                <a:solidFill>
-                  <a:srgbClr val="14532D"/>
+              <a:rPr sz="1100" b="0">
+                <a:solidFill>
+                  <a:srgbClr val="166534"/>
                 </a:solidFill>
                 <a:latin typeface="Inter"/>
               </a:rPr>
-              <a:t>2 warps x 4 lanes</a:t>
+              <a:t>2 warps × 4 lanes</a:t>
             </a:r>
-            <a:endParaRPr sz="1100">
+            <a:endParaRPr sz="1100" b="0">
               <a:solidFill>
-                <a:srgbClr val="14532D"/>
+                <a:srgbClr val="166534"/>
               </a:solidFill>
               <a:latin typeface="Inter"/>
             </a:endParaRPr>
@@ -4079,17 +6334,17 @@
           <a:p>
             <a:pPr algn="ctr"/>
             <a:r>
-              <a:rPr sz="1100">
-                <a:solidFill>
-                  <a:srgbClr val="14532D"/>
+              <a:rPr sz="1100" b="0">
+                <a:solidFill>
+                  <a:srgbClr val="166534"/>
                 </a:solidFill>
                 <a:latin typeface="Inter"/>
               </a:rPr>
               <a:t>8 physical threads</a:t>
             </a:r>
-            <a:endParaRPr sz="1100">
+            <a:endParaRPr sz="1100" b="0">
               <a:solidFill>
-                <a:srgbClr val="14532D"/>
+                <a:srgbClr val="166534"/>
               </a:solidFill>
               <a:latin typeface="Inter"/>
             </a:endParaRPr>
@@ -4097,17 +6352,17 @@
           <a:p>
             <a:pPr algn="ctr"/>
             <a:r>
-              <a:rPr sz="1100">
-                <a:solidFill>
-                  <a:srgbClr val="14532D"/>
+              <a:rPr sz="1100" b="0">
+                <a:solidFill>
+                  <a:srgbClr val="166534"/>
                 </a:solidFill>
                 <a:latin typeface="Inter"/>
               </a:rPr>
-              <a:t>DCR | dispatcher</a:t>
+              <a:t>DCR + dispatcher</a:t>
             </a:r>
-            <a:endParaRPr sz="1100">
+            <a:endParaRPr sz="1100" b="0">
               <a:solidFill>
-                <a:srgbClr val="14532D"/>
+                <a:srgbClr val="166534"/>
               </a:solidFill>
               <a:latin typeface="Inter"/>
             </a:endParaRPr>
@@ -4115,17 +6370,17 @@
           <a:p>
             <a:pPr algn="ctr"/>
             <a:r>
-              <a:rPr sz="1100">
-                <a:solidFill>
-                  <a:srgbClr val="14532D"/>
+              <a:rPr sz="1100" b="0">
+                <a:solidFill>
+                  <a:srgbClr val="166534"/>
                 </a:solidFill>
                 <a:latin typeface="Inter"/>
               </a:rPr>
               <a:t>16-bit custom ISA</a:t>
             </a:r>
-            <a:endParaRPr sz="1100">
+            <a:endParaRPr sz="1100" b="0">
               <a:solidFill>
-                <a:srgbClr val="14532D"/>
+                <a:srgbClr val="166534"/>
               </a:solidFill>
               <a:latin typeface="Inter"/>
             </a:endParaRPr>
@@ -4134,24 +6389,82 @@
       </p:sp>
       <p:sp>
         <p:nvSpPr>
-          <p:cNvPr id="287" name="Rectangle 28"/>
+          <p:cNvPr id="388" name="TextBox 76"/>
+          <p:cNvSpPr txBox="1"/>
+          <p:nvPr/>
+        </p:nvSpPr>
+        <p:spPr>
+          <a:xfrm>
+            <a:off x="9232900" y="3289300"/>
+            <a:ext cx="1905000" cy="277368"/>
+          </a:xfrm>
+          <a:prstGeom prst="rect">
+            <a:avLst/>
+          </a:prstGeom>
+        </p:spPr>
+        <p:txBody>
+          <a:bodyPr wrap="square" lIns="0" tIns="0" rIns="0" bIns="0" anchor="ctr">
+            <a:normAutofit fontScale="100000"/>
+          </a:bodyPr>
+          <a:lstStyle/>
+          <a:p>
+            <a:pPr algn="ctr"/>
+            <a:r>
+              <a:rPr sz="910" b="0">
+                <a:solidFill>
+                  <a:srgbClr val="166534"/>
+                </a:solidFill>
+                <a:latin typeface="Inter"/>
+              </a:rPr>
+              <a:t>active config snapshot</a:t>
+            </a:r>
+            <a:endParaRPr sz="910" b="0">
+              <a:solidFill>
+                <a:srgbClr val="166534"/>
+              </a:solidFill>
+              <a:latin typeface="Inter"/>
+            </a:endParaRPr>
+          </a:p>
+          <a:p>
+            <a:pPr algn="ctr"/>
+            <a:r>
+              <a:rPr sz="910" b="0">
+                <a:solidFill>
+                  <a:srgbClr val="166534"/>
+                </a:solidFill>
+                <a:latin typeface="Inter"/>
+              </a:rPr>
+              <a:t>owner-locked memory grant</a:t>
+            </a:r>
+            <a:endParaRPr sz="910" b="0">
+              <a:solidFill>
+                <a:srgbClr val="166534"/>
+              </a:solidFill>
+              <a:latin typeface="Inter"/>
+            </a:endParaRPr>
+          </a:p>
+        </p:txBody>
+      </p:sp>
+      <p:sp>
+        <p:nvSpPr>
+          <p:cNvPr id="389" name="Rectangle 77"/>
           <p:cNvSpPr/>
           <p:nvPr/>
         </p:nvSpPr>
         <p:spPr>
           <a:xfrm>
-            <a:off x="4191000" y="4699000"/>
-            <a:ext cx="3810000" cy="1524000"/>
+            <a:off x="9042400" y="5168900"/>
+            <a:ext cx="2286000" cy="812800"/>
           </a:xfrm>
           <a:prstGeom prst="roundRect">
             <a:avLst/>
           </a:prstGeom>
           <a:solidFill>
-            <a:srgbClr val="E0E7FF"/>
+            <a:srgbClr val="F1F5F9"/>
           </a:solidFill>
-          <a:ln w="31750">
+          <a:ln w="20320">
             <a:solidFill>
-              <a:srgbClr val="4F46E5"/>
+              <a:srgbClr val="64748B"/>
             </a:solidFill>
           </a:ln>
         </p:spPr>
@@ -4172,204 +6485,43 @@
           </a:fontRef>
         </p:style>
         <p:txBody>
-          <a:bodyPr/>
+          <a:bodyPr anchor="ctr"/>
           <a:lstStyle/>
           <a:p/>
         </p:txBody>
       </p:sp>
       <p:sp>
         <p:nvSpPr>
-          <p:cNvPr id="288" name="TextBox 29"/>
+          <p:cNvPr id="390" name="TextBox 78"/>
           <p:cNvSpPr txBox="1"/>
           <p:nvPr/>
         </p:nvSpPr>
         <p:spPr>
           <a:xfrm>
-            <a:off x="4381500" y="4876800"/>
-            <a:ext cx="3429000" cy="352671"/>
-          </a:xfrm>
-          <a:prstGeom prst="rect">
-            <a:avLst/>
-          </a:prstGeom>
-        </p:spPr>
-        <p:txBody>
-          <a:bodyPr wrap="square" anchor="ctr">
-            <a:spAutoFit/>
+            <a:off x="9207500" y="5257800"/>
+            <a:ext cx="1955800" cy="160020"/>
+          </a:xfrm>
+          <a:prstGeom prst="rect">
+            <a:avLst/>
+          </a:prstGeom>
+        </p:spPr>
+        <p:txBody>
+          <a:bodyPr wrap="square" lIns="0" tIns="0" rIns="0" bIns="0" anchor="ctr">
+            <a:normAutofit fontScale="100000"/>
           </a:bodyPr>
           <a:lstStyle/>
           <a:p>
             <a:pPr algn="ctr"/>
             <a:r>
-              <a:rPr sz="1700" b="1">
-                <a:solidFill>
-                  <a:srgbClr val="312E81"/>
+              <a:rPr sz="1050" b="1">
+                <a:solidFill>
+                  <a:srgbClr val="334155"/>
                 </a:solidFill>
                 <a:latin typeface="Inter"/>
               </a:rPr>
-              <a:t>Shared RAM</a:t>
+              <a:t>GPU PROGRAM MEMORY</a:t>
             </a:r>
-            <a:endParaRPr sz="1700" b="1">
-              <a:solidFill>
-                <a:srgbClr val="312E81"/>
-              </a:solidFill>
-              <a:latin typeface="Inter"/>
-            </a:endParaRPr>
-          </a:p>
-        </p:txBody>
-      </p:sp>
-      <p:sp>
-        <p:nvSpPr>
-          <p:cNvPr id="289" name="TextBox 30"/>
-          <p:cNvSpPr txBox="1"/>
-          <p:nvPr/>
-        </p:nvSpPr>
-        <p:spPr>
-          <a:xfrm>
-            <a:off x="4381500" y="5257800"/>
-            <a:ext cx="3429000" cy="621584"/>
-          </a:xfrm>
-          <a:prstGeom prst="rect">
-            <a:avLst/>
-          </a:prstGeom>
-        </p:spPr>
-        <p:txBody>
-          <a:bodyPr wrap="square" anchor="ctr">
-            <a:spAutoFit/>
-          </a:bodyPr>
-          <a:lstStyle/>
-          <a:p>
-            <a:pPr algn="ctr"/>
-            <a:r>
-              <a:rPr sz="1150">
-                <a:solidFill>
-                  <a:srgbClr val="312E81"/>
-                </a:solidFill>
-                <a:latin typeface="Inter"/>
-              </a:rPr>
-              <a:t>32K x 32 dual-port | host + pixel ports</a:t>
-            </a:r>
-            <a:endParaRPr sz="1150">
-              <a:solidFill>
-                <a:srgbClr val="312E81"/>
-              </a:solidFill>
-              <a:latin typeface="Inter"/>
-            </a:endParaRPr>
-          </a:p>
-          <a:p>
-            <a:pPr algn="ctr"/>
-            <a:r>
-              <a:rPr sz="1150">
-                <a:solidFill>
-                  <a:srgbClr val="312E81"/>
-                </a:solidFill>
-                <a:latin typeface="Inter"/>
-              </a:rPr>
-              <a:t>Framebuffer A (src) 0x2000</a:t>
-            </a:r>
-            <a:endParaRPr sz="1150">
-              <a:solidFill>
-                <a:srgbClr val="312E81"/>
-              </a:solidFill>
-              <a:latin typeface="Inter"/>
-            </a:endParaRPr>
-          </a:p>
-          <a:p>
-            <a:pPr algn="ctr"/>
-            <a:r>
-              <a:rPr sz="1150">
-                <a:solidFill>
-                  <a:srgbClr val="312E81"/>
-                </a:solidFill>
-                <a:latin typeface="Inter"/>
-              </a:rPr>
-              <a:t>Framebuffer B (dst) 0x6000</a:t>
-            </a:r>
-            <a:endParaRPr sz="1150">
-              <a:solidFill>
-                <a:srgbClr val="312E81"/>
-              </a:solidFill>
-              <a:latin typeface="Inter"/>
-            </a:endParaRPr>
-          </a:p>
-        </p:txBody>
-      </p:sp>
-      <p:sp>
-        <p:nvSpPr>
-          <p:cNvPr id="290" name="Rectangle 31"/>
-          <p:cNvSpPr/>
-          <p:nvPr/>
-        </p:nvSpPr>
-        <p:spPr>
-          <a:xfrm>
-            <a:off x="9271000" y="4699000"/>
-            <a:ext cx="2476500" cy="1397000"/>
-          </a:xfrm>
-          <a:prstGeom prst="roundRect">
-            <a:avLst/>
-          </a:prstGeom>
-          <a:solidFill>
-            <a:srgbClr val="F1F5F9"/>
-          </a:solidFill>
-          <a:ln w="25400">
-            <a:solidFill>
-              <a:srgbClr val="64748B"/>
-            </a:solidFill>
-          </a:ln>
-        </p:spPr>
-        <p:style>
-          <a:lnRef idx="2">
-            <a:schemeClr val="accent1">
-              <a:shade val="50000"/>
-            </a:schemeClr>
-          </a:lnRef>
-          <a:fillRef idx="1">
-            <a:schemeClr val="accent1"/>
-          </a:fillRef>
-          <a:effectRef idx="0">
-            <a:schemeClr val="accent1"/>
-          </a:effectRef>
-          <a:fontRef idx="minor">
-            <a:schemeClr val="lt1"/>
-          </a:fontRef>
-        </p:style>
-        <p:txBody>
-          <a:bodyPr/>
-          <a:lstStyle/>
-          <a:p/>
-        </p:txBody>
-      </p:sp>
-      <p:sp>
-        <p:nvSpPr>
-          <p:cNvPr id="291" name="TextBox 32"/>
-          <p:cNvSpPr txBox="1"/>
-          <p:nvPr/>
-        </p:nvSpPr>
-        <p:spPr>
-          <a:xfrm>
-            <a:off x="9398000" y="4889500"/>
-            <a:ext cx="2222500" cy="306571"/>
-          </a:xfrm>
-          <a:prstGeom prst="rect">
-            <a:avLst/>
-          </a:prstGeom>
-        </p:spPr>
-        <p:txBody>
-          <a:bodyPr wrap="square" anchor="ctr">
-            <a:spAutoFit/>
-          </a:bodyPr>
-          <a:lstStyle/>
-          <a:p>
-            <a:pPr algn="ctr"/>
-            <a:r>
-              <a:rPr sz="1400" b="1">
-                <a:solidFill>
-                  <a:srgbClr val="334155"/>
-                </a:solidFill>
-                <a:latin typeface="Inter"/>
-              </a:rPr>
-              <a:t>GPU Program Memory</a:t>
-            </a:r>
-            <a:endParaRPr sz="1400" b="1">
+            <a:endParaRPr sz="1050" b="1">
               <a:solidFill>
                 <a:srgbClr val="334155"/>
               </a:solidFill>
@@ -4380,352 +6532,94 @@
       </p:sp>
       <p:sp>
         <p:nvSpPr>
-          <p:cNvPr id="292" name="TextBox 33"/>
+          <p:cNvPr id="391" name="TextBox 79"/>
           <p:cNvSpPr txBox="1"/>
           <p:nvPr/>
         </p:nvSpPr>
         <p:spPr>
           <a:xfrm>
-            <a:off x="9398000" y="5270500"/>
-            <a:ext cx="2222500" cy="594360"/>
-          </a:xfrm>
-          <a:prstGeom prst="rect">
-            <a:avLst/>
-          </a:prstGeom>
-        </p:spPr>
-        <p:txBody>
-          <a:bodyPr wrap="square" anchor="ctr">
-            <a:spAutoFit/>
+            <a:off x="9207500" y="5537200"/>
+            <a:ext cx="1955800" cy="268224"/>
+          </a:xfrm>
+          <a:prstGeom prst="rect">
+            <a:avLst/>
+          </a:prstGeom>
+        </p:spPr>
+        <p:txBody>
+          <a:bodyPr wrap="square" lIns="0" tIns="0" rIns="0" bIns="0" anchor="ctr">
+            <a:normAutofit fontScale="100000"/>
           </a:bodyPr>
           <a:lstStyle/>
           <a:p>
             <a:pPr algn="ctr"/>
             <a:r>
-              <a:rPr sz="1100">
-                <a:solidFill>
-                  <a:srgbClr val="334155"/>
+              <a:rPr sz="880" b="0">
+                <a:solidFill>
+                  <a:srgbClr val="475569"/>
                 </a:solidFill>
                 <a:latin typeface="Inter"/>
               </a:rPr>
-              <a:t>1024 x 16-bit</a:t>
+              <a:t>GPU-local instruction fetch</a:t>
             </a:r>
-          </a:p>
-          <a:p>
-            <a:pPr algn="ctr"/>
-            <a:r>
-              <a:rPr sz="1100">
-                <a:solidFill>
-                  <a:srgbClr val="334155"/>
-                </a:solidFill>
-                <a:latin typeface="Inter"/>
-              </a:rPr>
-              <a:t>Blur kernel</a:t>
-            </a:r>
-          </a:p>
-          <a:p>
-            <a:pPr algn="ctr"/>
-            <a:r>
-              <a:rPr sz="1100">
-                <a:solidFill>
-                  <a:srgbClr val="334155"/>
-                </a:solidFill>
-                <a:latin typeface="Inter"/>
-              </a:rPr>
-              <a:t>Brighten kernel</a:t>
-            </a:r>
-          </a:p>
-        </p:txBody>
-      </p:sp>
-      <p:sp>
-        <p:nvSpPr>
-          <p:cNvPr id="293" name="TextBox 34"/>
-          <p:cNvSpPr txBox="1"/>
-          <p:nvPr/>
-        </p:nvSpPr>
-        <p:spPr>
-          <a:xfrm>
-            <a:off x="3746500" y="2717800"/>
-            <a:ext cx="863600" cy="482600"/>
-          </a:xfrm>
-          <a:prstGeom prst="rect">
-            <a:avLst/>
-          </a:prstGeom>
-        </p:spPr>
-        <p:txBody>
-          <a:bodyPr wrap="square">
-            <a:spAutoFit/>
-          </a:bodyPr>
-          <a:lstStyle/>
-          <a:p>
-            <a:pPr algn="ctr"/>
-            <a:r>
-              <a:rPr sz="900">
-                <a:solidFill>
-                  <a:srgbClr val="1D4ED8"/>
-                </a:solidFill>
-                <a:latin typeface="Inter"/>
-              </a:rPr>
-              <a:t>CPU AXI master</a:t>
-            </a:r>
-            <a:endParaRPr sz="900">
-              <a:solidFill>
-                <a:srgbClr val="1D4ED8"/>
-              </a:solidFill>
-              <a:latin typeface="Inter"/>
-            </a:endParaRPr>
-          </a:p>
-        </p:txBody>
-      </p:sp>
-      <p:sp>
-        <p:nvSpPr>
-          <p:cNvPr id="294" name="TextBox 35"/>
-          <p:cNvSpPr txBox="1"/>
-          <p:nvPr/>
-        </p:nvSpPr>
-        <p:spPr>
-          <a:xfrm>
-            <a:off x="7556500" y="2717800"/>
-            <a:ext cx="698500" cy="482600"/>
-          </a:xfrm>
-          <a:prstGeom prst="rect">
-            <a:avLst/>
-          </a:prstGeom>
-        </p:spPr>
-        <p:txBody>
-          <a:bodyPr wrap="square">
-            <a:spAutoFit/>
-          </a:bodyPr>
-          <a:lstStyle/>
-          <a:p>
-            <a:pPr algn="ctr"/>
-            <a:r>
-              <a:rPr sz="900">
-                <a:solidFill>
-                  <a:srgbClr val="7E22CE"/>
-                </a:solidFill>
-                <a:latin typeface="Inter"/>
-              </a:rPr>
-              <a:t>AXI MMIO</a:t>
-            </a:r>
-            <a:endParaRPr sz="900">
-              <a:solidFill>
-                <a:srgbClr val="7E22CE"/>
-              </a:solidFill>
-              <a:latin typeface="Inter"/>
-            </a:endParaRPr>
-          </a:p>
-        </p:txBody>
-      </p:sp>
-      <p:sp>
-        <p:nvSpPr>
-          <p:cNvPr id="295" name="TextBox 36"/>
-          <p:cNvSpPr txBox="1"/>
-          <p:nvPr/>
-        </p:nvSpPr>
-        <p:spPr>
-          <a:xfrm>
-            <a:off x="6096000" y="4152900"/>
-            <a:ext cx="1524000" cy="229739"/>
-          </a:xfrm>
-          <a:prstGeom prst="rect">
-            <a:avLst/>
-          </a:prstGeom>
-        </p:spPr>
-        <p:txBody>
-          <a:bodyPr wrap="square">
-            <a:spAutoFit/>
-          </a:bodyPr>
-          <a:lstStyle/>
-          <a:p>
-            <a:pPr algn="ctr"/>
-            <a:r>
-              <a:rPr sz="900">
-                <a:solidFill>
-                  <a:srgbClr val="1D4ED8"/>
-                </a:solidFill>
-                <a:latin typeface="Inter"/>
-              </a:rPr>
-              <a:t>AXI RAM host port</a:t>
-            </a:r>
-            <a:endParaRPr sz="900">
-              <a:solidFill>
-                <a:srgbClr val="1D4ED8"/>
-              </a:solidFill>
-              <a:latin typeface="Inter"/>
-            </a:endParaRPr>
-          </a:p>
-        </p:txBody>
-      </p:sp>
-      <p:sp>
-        <p:nvSpPr>
-          <p:cNvPr id="296" name="TextBox 37"/>
-          <p:cNvSpPr txBox="1"/>
-          <p:nvPr/>
-        </p:nvSpPr>
-        <p:spPr>
-          <a:xfrm>
-            <a:off x="9525000" y="1841500"/>
-            <a:ext cx="1016000" cy="228600"/>
-          </a:xfrm>
-          <a:prstGeom prst="rect">
-            <a:avLst/>
-          </a:prstGeom>
-        </p:spPr>
-        <p:txBody>
-          <a:bodyPr wrap="square">
-            <a:spAutoFit/>
-          </a:bodyPr>
-          <a:lstStyle/>
-          <a:p>
-            <a:pPr algn="ctr"/>
-            <a:r>
-              <a:rPr sz="900">
-                <a:solidFill>
-                  <a:srgbClr val="7E22CE"/>
-                </a:solidFill>
-                <a:latin typeface="Inter"/>
-              </a:rPr>
-              <a:t>GPU control</a:t>
-            </a:r>
-            <a:endParaRPr sz="900">
-              <a:solidFill>
-                <a:srgbClr val="7E22CE"/>
-              </a:solidFill>
-              <a:latin typeface="Inter"/>
-            </a:endParaRPr>
-          </a:p>
-        </p:txBody>
-      </p:sp>
-      <p:sp>
-        <p:nvSpPr>
-          <p:cNvPr id="297" name="TextBox 38"/>
-          <p:cNvSpPr txBox="1"/>
-          <p:nvPr/>
-        </p:nvSpPr>
-        <p:spPr>
-          <a:xfrm>
-            <a:off x="7937500" y="4089400"/>
-            <a:ext cx="1587500" cy="381000"/>
-          </a:xfrm>
-          <a:prstGeom prst="rect">
-            <a:avLst/>
-          </a:prstGeom>
-        </p:spPr>
-        <p:txBody>
-          <a:bodyPr wrap="square">
-            <a:spAutoFit/>
-          </a:bodyPr>
-          <a:lstStyle/>
-          <a:p>
-            <a:pPr algn="ctr"/>
-            <a:r>
-              <a:rPr sz="900">
-                <a:solidFill>
-                  <a:srgbClr val="15803D"/>
-                </a:solidFill>
-                <a:latin typeface="Inter"/>
-              </a:rPr>
-              <a:t>GPU pixel bus</a:t>
-            </a:r>
-            <a:endParaRPr sz="900">
-              <a:solidFill>
-                <a:srgbClr val="15803D"/>
-              </a:solidFill>
-              <a:latin typeface="Inter"/>
-            </a:endParaRPr>
-          </a:p>
-          <a:p>
-            <a:pPr algn="ctr"/>
-            <a:r>
-              <a:rPr sz="900">
-                <a:solidFill>
-                  <a:srgbClr val="15803D"/>
-                </a:solidFill>
-                <a:latin typeface="Inter"/>
-              </a:rPr>
-              <a:t>(word addressed)</a:t>
-            </a:r>
-            <a:endParaRPr sz="900">
-              <a:solidFill>
-                <a:srgbClr val="15803D"/>
-              </a:solidFill>
-              <a:latin typeface="Inter"/>
-            </a:endParaRPr>
-          </a:p>
-        </p:txBody>
-      </p:sp>
-      <p:sp>
-        <p:nvSpPr>
-          <p:cNvPr id="298" name="TextBox 39"/>
-          <p:cNvSpPr txBox="1"/>
-          <p:nvPr/>
-        </p:nvSpPr>
-        <p:spPr>
-          <a:xfrm>
-            <a:off x="10566400" y="4343400"/>
-            <a:ext cx="1143000" cy="228600"/>
-          </a:xfrm>
-          <a:prstGeom prst="rect">
-            <a:avLst/>
-          </a:prstGeom>
-        </p:spPr>
-        <p:txBody>
-          <a:bodyPr wrap="square">
-            <a:spAutoFit/>
-          </a:bodyPr>
-          <a:lstStyle/>
-          <a:p>
-            <a:pPr algn="ctr"/>
-            <a:r>
-              <a:rPr sz="900">
-                <a:solidFill>
-                  <a:srgbClr val="475569"/>
-                </a:solidFill>
-                <a:latin typeface="Inter"/>
-              </a:rPr>
-              <a:t>Instruction fetch</a:t>
-            </a:r>
-            <a:endParaRPr sz="900">
+            <a:endParaRPr sz="880" b="0">
               <a:solidFill>
                 <a:srgbClr val="475569"/>
               </a:solidFill>
               <a:latin typeface="Inter"/>
             </a:endParaRPr>
           </a:p>
-        </p:txBody>
-      </p:sp>
-      <p:sp>
-        <p:nvSpPr>
-          <p:cNvPr id="299" name="TextBox 40"/>
-          <p:cNvSpPr txBox="1"/>
-          <p:nvPr/>
-        </p:nvSpPr>
-        <p:spPr>
-          <a:xfrm>
-            <a:off x="508000" y="6451600"/>
-            <a:ext cx="11176000" cy="237422"/>
-          </a:xfrm>
-          <a:prstGeom prst="rect">
-            <a:avLst/>
-          </a:prstGeom>
-        </p:spPr>
-        <p:txBody>
-          <a:bodyPr wrap="square" anchor="ctr">
-            <a:spAutoFit/>
-          </a:bodyPr>
-          <a:lstStyle/>
           <a:p>
             <a:pPr algn="ctr"/>
             <a:r>
-              <a:rPr sz="950">
-                <a:solidFill>
-                  <a:srgbClr val="64748B"/>
+              <a:rPr sz="880" b="0">
+                <a:solidFill>
+                  <a:srgbClr val="475569"/>
                 </a:solidFill>
                 <a:latin typeface="Inter"/>
               </a:rPr>
-              <a:t>Blue: AXI4-Lite   |   Purple: GPU control   |   Green: pixel data   |   Gray: private fetch and clock</a:t>
+              <a:t>booted through CDC</a:t>
             </a:r>
-            <a:endParaRPr sz="950">
+            <a:endParaRPr sz="880" b="0">
+              <a:solidFill>
+                <a:srgbClr val="475569"/>
+              </a:solidFill>
+              <a:latin typeface="Inter"/>
+            </a:endParaRPr>
+          </a:p>
+        </p:txBody>
+      </p:sp>
+      <p:sp>
+        <p:nvSpPr>
+          <p:cNvPr id="392" name="TextBox 80"/>
+          <p:cNvSpPr txBox="1"/>
+          <p:nvPr/>
+        </p:nvSpPr>
+        <p:spPr>
+          <a:xfrm>
+            <a:off x="546100" y="6362700"/>
+            <a:ext cx="11099800" cy="134112"/>
+          </a:xfrm>
+          <a:prstGeom prst="rect">
+            <a:avLst/>
+          </a:prstGeom>
+        </p:spPr>
+        <p:txBody>
+          <a:bodyPr wrap="square" lIns="0" tIns="0" rIns="0" bIns="0" anchor="ctr">
+            <a:normAutofit fontScale="100000"/>
+          </a:bodyPr>
+          <a:lstStyle/>
+          <a:p>
+            <a:pPr algn="ctr"/>
+            <a:r>
+              <a:rPr sz="880" b="0">
+                <a:solidFill>
+                  <a:srgbClr val="64748B"/>
+                </a:solidFill>
+                <a:latin typeface="Inter"/>
+              </a:rPr>
+              <a:t>Blue: CPU data path   •   Amber: AXI4-Lite   •   Purple: control/status CDC   •   Green: GPU memory CDC   •   Gray: private instruction path</a:t>
+            </a:r>
+            <a:endParaRPr sz="880" b="0">
               <a:solidFill>
                 <a:srgbClr val="64748B"/>
               </a:solidFill>

</xml_diff>